<commit_message>
Document verified public demo and update presentation deployment status
</commit_message>
<xml_diff>
--- a/docs/presentacion/FuelTrack-Presentacion.pptx
+++ b/docs/presentacion/FuelTrack-Presentacion.pptx
@@ -2,31 +2,31 @@
 <file path=ppt/presentation.xml><?xml version="1.0" encoding="utf-8"?>
 <p:presentation xmlns:p="http://schemas.openxmlformats.org/presentationml/2006/main">
   <p:sldMasterIdLst>
-    <p:sldMasterId xmlns:r="http://schemas.openxmlformats.org/officeDocument/2006/relationships" id="2147483648" r:id="R28fa4a467bbb4bc2"/>
+    <p:sldMasterId xmlns:r="http://schemas.openxmlformats.org/officeDocument/2006/relationships" id="2147483648" r:id="R249ed2e261a44841"/>
   </p:sldMasterIdLst>
   <p:notesMasterIdLst>
-    <p:notesMasterId xmlns:r="http://schemas.openxmlformats.org/officeDocument/2006/relationships" r:id="Rbf6cb99420d74c05"/>
+    <p:notesMasterId xmlns:r="http://schemas.openxmlformats.org/officeDocument/2006/relationships" r:id="Re549598e1cea4625"/>
   </p:notesMasterIdLst>
   <p:sldIdLst>
-    <p:sldId xmlns:r="http://schemas.openxmlformats.org/officeDocument/2006/relationships" id="256" r:id="R68146a545585423f"/>
-    <p:sldId xmlns:r="http://schemas.openxmlformats.org/officeDocument/2006/relationships" id="257" r:id="R342358756da34142"/>
-    <p:sldId xmlns:r="http://schemas.openxmlformats.org/officeDocument/2006/relationships" id="258" r:id="R57761686bfdd42b1"/>
-    <p:sldId xmlns:r="http://schemas.openxmlformats.org/officeDocument/2006/relationships" id="259" r:id="R924808d6a3ac4a80"/>
-    <p:sldId xmlns:r="http://schemas.openxmlformats.org/officeDocument/2006/relationships" id="260" r:id="R204a7534cc6f4ea1"/>
-    <p:sldId xmlns:r="http://schemas.openxmlformats.org/officeDocument/2006/relationships" id="261" r:id="R5a3bff9509a34607"/>
-    <p:sldId xmlns:r="http://schemas.openxmlformats.org/officeDocument/2006/relationships" id="262" r:id="Reeb268ea526e49fd"/>
-    <p:sldId xmlns:r="http://schemas.openxmlformats.org/officeDocument/2006/relationships" id="263" r:id="R91c18fdc248049b3"/>
-    <p:sldId xmlns:r="http://schemas.openxmlformats.org/officeDocument/2006/relationships" id="264" r:id="Rc5efe66152f24eec"/>
-    <p:sldId xmlns:r="http://schemas.openxmlformats.org/officeDocument/2006/relationships" id="265" r:id="R918290fdbadb49d5"/>
-    <p:sldId xmlns:r="http://schemas.openxmlformats.org/officeDocument/2006/relationships" id="266" r:id="Rb257bfc5520244d0"/>
-    <p:sldId xmlns:r="http://schemas.openxmlformats.org/officeDocument/2006/relationships" id="267" r:id="R208db10379864945"/>
-    <p:sldId xmlns:r="http://schemas.openxmlformats.org/officeDocument/2006/relationships" id="268" r:id="Rb73375207a8a443f"/>
-    <p:sldId xmlns:r="http://schemas.openxmlformats.org/officeDocument/2006/relationships" id="269" r:id="R6fdd365000084bee"/>
-    <p:sldId xmlns:r="http://schemas.openxmlformats.org/officeDocument/2006/relationships" id="270" r:id="Rc4741ad284cc49c8"/>
-    <p:sldId xmlns:r="http://schemas.openxmlformats.org/officeDocument/2006/relationships" id="271" r:id="R9b2c98082238402c"/>
-    <p:sldId xmlns:r="http://schemas.openxmlformats.org/officeDocument/2006/relationships" id="272" r:id="R52086432959644a7"/>
-    <p:sldId xmlns:r="http://schemas.openxmlformats.org/officeDocument/2006/relationships" id="273" r:id="R8bbc6d9f49d04d1b"/>
-    <p:sldId xmlns:r="http://schemas.openxmlformats.org/officeDocument/2006/relationships" id="274" r:id="R86246d43eaa74b31"/>
+    <p:sldId xmlns:r="http://schemas.openxmlformats.org/officeDocument/2006/relationships" id="256" r:id="R68b5a101d56142b2"/>
+    <p:sldId xmlns:r="http://schemas.openxmlformats.org/officeDocument/2006/relationships" id="257" r:id="R5322464f38bc48a2"/>
+    <p:sldId xmlns:r="http://schemas.openxmlformats.org/officeDocument/2006/relationships" id="258" r:id="Rdf8520ec92b840c6"/>
+    <p:sldId xmlns:r="http://schemas.openxmlformats.org/officeDocument/2006/relationships" id="259" r:id="R498746f0c52b45fd"/>
+    <p:sldId xmlns:r="http://schemas.openxmlformats.org/officeDocument/2006/relationships" id="260" r:id="R19185fd936b245af"/>
+    <p:sldId xmlns:r="http://schemas.openxmlformats.org/officeDocument/2006/relationships" id="261" r:id="Rf992b93d60ad4f4a"/>
+    <p:sldId xmlns:r="http://schemas.openxmlformats.org/officeDocument/2006/relationships" id="262" r:id="R6abc4419334f4159"/>
+    <p:sldId xmlns:r="http://schemas.openxmlformats.org/officeDocument/2006/relationships" id="263" r:id="R682ff533a5f243ad"/>
+    <p:sldId xmlns:r="http://schemas.openxmlformats.org/officeDocument/2006/relationships" id="264" r:id="Ra4d32891044a4965"/>
+    <p:sldId xmlns:r="http://schemas.openxmlformats.org/officeDocument/2006/relationships" id="265" r:id="Ra52783ee867b44ab"/>
+    <p:sldId xmlns:r="http://schemas.openxmlformats.org/officeDocument/2006/relationships" id="266" r:id="Rd30f23b98ef24a29"/>
+    <p:sldId xmlns:r="http://schemas.openxmlformats.org/officeDocument/2006/relationships" id="267" r:id="R9551f23c29e54ad8"/>
+    <p:sldId xmlns:r="http://schemas.openxmlformats.org/officeDocument/2006/relationships" id="268" r:id="R2b1a8d161b2b49a8"/>
+    <p:sldId xmlns:r="http://schemas.openxmlformats.org/officeDocument/2006/relationships" id="269" r:id="Rdb2cf3f2acd34d40"/>
+    <p:sldId xmlns:r="http://schemas.openxmlformats.org/officeDocument/2006/relationships" id="270" r:id="Ra5b51adb6c6d46e4"/>
+    <p:sldId xmlns:r="http://schemas.openxmlformats.org/officeDocument/2006/relationships" id="271" r:id="Rc0acfe25b8aa48a2"/>
+    <p:sldId xmlns:r="http://schemas.openxmlformats.org/officeDocument/2006/relationships" id="272" r:id="R96f1b462796b4272"/>
+    <p:sldId xmlns:r="http://schemas.openxmlformats.org/officeDocument/2006/relationships" id="273" r:id="R39d7f59627584e10"/>
+    <p:sldId xmlns:r="http://schemas.openxmlformats.org/officeDocument/2006/relationships" id="274" r:id="Raa8fb8b476c24578"/>
   </p:sldIdLst>
   <p:sldSz cx="12192000" cy="6858000"/>
   <p:notesSz cx="6858000" cy="9144000"/>
@@ -1090,7 +1090,7 @@
           <a:lstStyle xmlns:a="http://schemas.openxmlformats.org/drawingml/2006/main"/>
           <a:p xmlns:a="http://schemas.openxmlformats.org/drawingml/2006/main">
             <a:r>
-              <a:t>La matriz adjunta cruza los 24 requisitos funcionales, los seis de seguridad, la arquitectura y siete criterios de aceptación. La demo local no acredita operación en producción. Requieren cierre externo: SMS y correo real en el entorno objetivo, cámara/lector físico, login nativo de Keycloak y despliegue con TLS 1.3/AES-256, backups, restauración y disponibilidad. La distribución Android actual es QA/debug. No afirmar 100% del SRS.</a:t>
+              <a:t>La matriz adjunta cruza los 24 requisitos funcionales, los seis de seguridad, la arquitectura y siete criterios de aceptación. Demo HTTPS publicada en https://fueltrack-intec-demo.onrender.com con Render Free y Neon. Verificados TLS 1.3, cinco roles, permisos, sobrecapacidad, QR inválido y PDF; esto no acredita operación productiva continua. Requieren cierre externo: SMS y correo real en el entorno objetivo, cámara/lector físico, login nativo de Keycloak y cifrado AES-256 en reposo, backups, restauración y disponibilidad. La distribución Android actual es QA/debug. No afirmar 100% del SRS.</a:t>
             </a:r>
           </a:p>
         </p:txBody>
@@ -1788,7 +1788,7 @@
   </p:cSld>
   <p:clrMap bg1="lt1" tx1="dk1" bg2="lt2" tx2="dk2" accent1="accent1" accent2="accent2" accent3="accent3" accent4="accent4" accent5="accent5" accent6="accent6" hlink="hlink" folHlink="folHlink"/>
   <p:sldLayoutIdLst>
-    <p:sldLayoutId xmlns:r="http://schemas.openxmlformats.org/officeDocument/2006/relationships" id="2147483649" r:id="Rfcf84dcae59c44f6"/>
+    <p:sldLayoutId xmlns:r="http://schemas.openxmlformats.org/officeDocument/2006/relationships" id="2147483649" r:id="R4008f90aefbb456e"/>
   </p:sldLayoutIdLst>
   <p:txStyles>
     <p:titleStyle>
@@ -2339,7 +2339,7 @@
           <p:cNvPr id="7" name="">
             <a:extLst xmlns:a="http://schemas.openxmlformats.org/drawingml/2006/main">
               <a:ext uri="{FF2B5EF4-FFF2-40B4-BE49-F238E27FC236}">
-                <a16:creationId xmlns:a16="http://schemas.microsoft.com/office/drawing/2014/main" id="{7FD3641A-2A17-4A51-89DB-93EB28F9D2F9}"/>
+                <a16:creationId xmlns:a16="http://schemas.microsoft.com/office/drawing/2014/main" id="{342BFBC2-0A1A-47CF-99B4-9F02890EF78C}"/>
               </a:ext>
             </a:extLst>
           </p:cNvPr>
@@ -2396,7 +2396,7 @@
           <p:cNvPr id="2" name="">
             <a:extLst xmlns:a="http://schemas.openxmlformats.org/drawingml/2006/main">
               <a:ext uri="{FF2B5EF4-FFF2-40B4-BE49-F238E27FC236}">
-                <a16:creationId xmlns:a16="http://schemas.microsoft.com/office/drawing/2014/main" id="{309649EC-787C-4A50-A36A-E400FD906E4B}"/>
+                <a16:creationId xmlns:a16="http://schemas.microsoft.com/office/drawing/2014/main" id="{3757F878-3C7B-4205-8D1E-5CD874A5EF7E}"/>
               </a:ext>
             </a:extLst>
           </p:cNvPr>
@@ -2453,7 +2453,7 @@
           <p:cNvPr id="3" name="">
             <a:extLst xmlns:a="http://schemas.openxmlformats.org/drawingml/2006/main">
               <a:ext uri="{FF2B5EF4-FFF2-40B4-BE49-F238E27FC236}">
-                <a16:creationId xmlns:a16="http://schemas.microsoft.com/office/drawing/2014/main" id="{39FFE847-A093-4D22-B21E-8FD1C8403CC2}"/>
+                <a16:creationId xmlns:a16="http://schemas.microsoft.com/office/drawing/2014/main" id="{5E0CCEAD-447F-4A7C-8DF0-7FF3916FDF54}"/>
               </a:ext>
             </a:extLst>
           </p:cNvPr>
@@ -2533,7 +2533,7 @@
           <p:cNvPr id="4" name="">
             <a:extLst xmlns:a="http://schemas.openxmlformats.org/drawingml/2006/main">
               <a:ext uri="{FF2B5EF4-FFF2-40B4-BE49-F238E27FC236}">
-                <a16:creationId xmlns:a16="http://schemas.microsoft.com/office/drawing/2014/main" id="{0B736B9B-64B6-43C1-B06B-35F5B5F571AA}"/>
+                <a16:creationId xmlns:a16="http://schemas.microsoft.com/office/drawing/2014/main" id="{5C0B0A9F-9B97-4C09-88EB-7E69637EE927}"/>
               </a:ext>
             </a:extLst>
           </p:cNvPr>
@@ -2590,7 +2590,7 @@
           <p:cNvPr id="5" name="">
             <a:extLst xmlns:a="http://schemas.openxmlformats.org/drawingml/2006/main">
               <a:ext uri="{FF2B5EF4-FFF2-40B4-BE49-F238E27FC236}">
-                <a16:creationId xmlns:a16="http://schemas.microsoft.com/office/drawing/2014/main" id="{A794453D-C4B6-40CB-A35C-F94E5DC948F5}"/>
+                <a16:creationId xmlns:a16="http://schemas.microsoft.com/office/drawing/2014/main" id="{14ED29B4-1CD1-43FC-BC9B-8D7B79ACF592}"/>
               </a:ext>
             </a:extLst>
           </p:cNvPr>
@@ -2651,7 +2651,7 @@
           <p:nvPr/>
         </p:nvPicPr>
         <p:blipFill>
-          <a:blip xmlns:r="http://schemas.openxmlformats.org/officeDocument/2006/relationships" xmlns:a="http://schemas.openxmlformats.org/drawingml/2006/main" r:embed="R2100c966730c4810"/>
+          <a:blip xmlns:r="http://schemas.openxmlformats.org/officeDocument/2006/relationships" xmlns:a="http://schemas.openxmlformats.org/drawingml/2006/main" r:embed="Rf9043990f56f42a9"/>
           <a:stretch xmlns:a="http://schemas.openxmlformats.org/drawingml/2006/main"/>
         </p:blipFill>
         <p:spPr>
@@ -2667,7 +2667,7 @@
     </p:spTree>
     <p:extLst>
       <p:ext uri="{BB962C8B-B14F-4D97-AF65-F5344CB8AC3E}">
-        <p14:creationId xmlns:p14="http://schemas.microsoft.com/office/powerpoint/2010/main" val="2019234822"/>
+        <p14:creationId xmlns:p14="http://schemas.microsoft.com/office/powerpoint/2010/main" val="633881197"/>
       </p:ext>
     </p:extLst>
   </p:cSld>
@@ -2698,7 +2698,7 @@
           <p:cNvPr id="4" name="">
             <a:extLst xmlns:a="http://schemas.openxmlformats.org/drawingml/2006/main">
               <a:ext uri="{FF2B5EF4-FFF2-40B4-BE49-F238E27FC236}">
-                <a16:creationId xmlns:a16="http://schemas.microsoft.com/office/drawing/2014/main" id="{0F845689-BE1D-4C91-BCFC-3A9D03317023}"/>
+                <a16:creationId xmlns:a16="http://schemas.microsoft.com/office/drawing/2014/main" id="{D75FC8C8-3384-482E-9D60-53FFBAA3588C}"/>
               </a:ext>
             </a:extLst>
           </p:cNvPr>
@@ -2755,7 +2755,7 @@
           <p:cNvPr id="2" name="">
             <a:extLst xmlns:a="http://schemas.openxmlformats.org/drawingml/2006/main">
               <a:ext uri="{FF2B5EF4-FFF2-40B4-BE49-F238E27FC236}">
-                <a16:creationId xmlns:a16="http://schemas.microsoft.com/office/drawing/2014/main" id="{6A05924E-75D2-48A0-8445-C950425F0239}"/>
+                <a16:creationId xmlns:a16="http://schemas.microsoft.com/office/drawing/2014/main" id="{9D439FFA-3A2F-4DA4-87A4-57B80604B516}"/>
               </a:ext>
             </a:extLst>
           </p:cNvPr>
@@ -2816,7 +2816,7 @@
           <p:nvPr/>
         </p:nvPicPr>
         <p:blipFill>
-          <a:blip xmlns:r="http://schemas.openxmlformats.org/officeDocument/2006/relationships" xmlns:a="http://schemas.openxmlformats.org/drawingml/2006/main" r:embed="R41bdad8472644189"/>
+          <a:blip xmlns:r="http://schemas.openxmlformats.org/officeDocument/2006/relationships" xmlns:a="http://schemas.openxmlformats.org/drawingml/2006/main" r:embed="R9faa7759f730412d"/>
           <a:stretch xmlns:a="http://schemas.openxmlformats.org/drawingml/2006/main"/>
         </p:blipFill>
         <p:spPr>
@@ -2832,7 +2832,7 @@
     </p:spTree>
     <p:extLst>
       <p:ext uri="{BB962C8B-B14F-4D97-AF65-F5344CB8AC3E}">
-        <p14:creationId xmlns:p14="http://schemas.microsoft.com/office/powerpoint/2010/main" val="1388340021"/>
+        <p14:creationId xmlns:p14="http://schemas.microsoft.com/office/powerpoint/2010/main" val="478463739"/>
       </p:ext>
     </p:extLst>
   </p:cSld>
@@ -2863,7 +2863,7 @@
           <p:cNvPr id="5" name="">
             <a:extLst xmlns:a="http://schemas.openxmlformats.org/drawingml/2006/main">
               <a:ext uri="{FF2B5EF4-FFF2-40B4-BE49-F238E27FC236}">
-                <a16:creationId xmlns:a16="http://schemas.microsoft.com/office/drawing/2014/main" id="{A3AACBDF-8227-4D22-8FC4-80EC2E697809}"/>
+                <a16:creationId xmlns:a16="http://schemas.microsoft.com/office/drawing/2014/main" id="{2C03F14A-06E2-402C-90CB-C1DEA808FA69}"/>
               </a:ext>
             </a:extLst>
           </p:cNvPr>
@@ -2920,7 +2920,7 @@
           <p:cNvPr id="2" name="">
             <a:extLst xmlns:a="http://schemas.openxmlformats.org/drawingml/2006/main">
               <a:ext uri="{FF2B5EF4-FFF2-40B4-BE49-F238E27FC236}">
-                <a16:creationId xmlns:a16="http://schemas.microsoft.com/office/drawing/2014/main" id="{68DB18CD-049F-4DB0-B02F-B8FC7DBB91F7}"/>
+                <a16:creationId xmlns:a16="http://schemas.microsoft.com/office/drawing/2014/main" id="{2D0C95E9-BE67-4488-9FE6-9C52DA57B5B4}"/>
               </a:ext>
             </a:extLst>
           </p:cNvPr>
@@ -2981,7 +2981,7 @@
           <p:nvPr/>
         </p:nvPicPr>
         <p:blipFill>
-          <a:blip xmlns:r="http://schemas.openxmlformats.org/officeDocument/2006/relationships" xmlns:a="http://schemas.openxmlformats.org/drawingml/2006/main" r:embed="Rfe6162f77fb9442e"/>
+          <a:blip xmlns:r="http://schemas.openxmlformats.org/officeDocument/2006/relationships" xmlns:a="http://schemas.openxmlformats.org/drawingml/2006/main" r:embed="R7036d46bf0484dc3"/>
           <a:stretch xmlns:a="http://schemas.openxmlformats.org/drawingml/2006/main"/>
         </p:blipFill>
         <p:spPr>
@@ -2999,7 +2999,7 @@
           <p:cNvPr id="4" name="">
             <a:extLst xmlns:a="http://schemas.openxmlformats.org/drawingml/2006/main">
               <a:ext uri="{FF2B5EF4-FFF2-40B4-BE49-F238E27FC236}">
-                <a16:creationId xmlns:a16="http://schemas.microsoft.com/office/drawing/2014/main" id="{E16B4783-C0FB-4418-A16F-FB92A2C433E4}"/>
+                <a16:creationId xmlns:a16="http://schemas.microsoft.com/office/drawing/2014/main" id="{F0186923-C0FD-4AC5-AE67-16675F0EF479}"/>
               </a:ext>
             </a:extLst>
           </p:cNvPr>
@@ -3138,7 +3138,7 @@
     </p:spTree>
     <p:extLst>
       <p:ext uri="{BB962C8B-B14F-4D97-AF65-F5344CB8AC3E}">
-        <p14:creationId xmlns:p14="http://schemas.microsoft.com/office/powerpoint/2010/main" val="416750965"/>
+        <p14:creationId xmlns:p14="http://schemas.microsoft.com/office/powerpoint/2010/main" val="491269211"/>
       </p:ext>
     </p:extLst>
   </p:cSld>
@@ -3169,7 +3169,7 @@
           <p:cNvPr id="5" name="">
             <a:extLst xmlns:a="http://schemas.openxmlformats.org/drawingml/2006/main">
               <a:ext uri="{FF2B5EF4-FFF2-40B4-BE49-F238E27FC236}">
-                <a16:creationId xmlns:a16="http://schemas.microsoft.com/office/drawing/2014/main" id="{4D3DC9CB-D452-4057-8BD0-76805D9D6DDB}"/>
+                <a16:creationId xmlns:a16="http://schemas.microsoft.com/office/drawing/2014/main" id="{AA8B8398-A24A-4EBF-8BDB-948B00AF6E8A}"/>
               </a:ext>
             </a:extLst>
           </p:cNvPr>
@@ -3226,7 +3226,7 @@
           <p:cNvPr id="2" name="">
             <a:extLst xmlns:a="http://schemas.openxmlformats.org/drawingml/2006/main">
               <a:ext uri="{FF2B5EF4-FFF2-40B4-BE49-F238E27FC236}">
-                <a16:creationId xmlns:a16="http://schemas.microsoft.com/office/drawing/2014/main" id="{18E86C37-163E-4CBB-B289-4876FC39979B}"/>
+                <a16:creationId xmlns:a16="http://schemas.microsoft.com/office/drawing/2014/main" id="{676C04DB-4BD1-45A6-9940-6A87BEB9F056}"/>
               </a:ext>
             </a:extLst>
           </p:cNvPr>
@@ -3750,7 +3750,7 @@
           <p:cNvPr id="4" name="">
             <a:extLst xmlns:a="http://schemas.openxmlformats.org/drawingml/2006/main">
               <a:ext uri="{FF2B5EF4-FFF2-40B4-BE49-F238E27FC236}">
-                <a16:creationId xmlns:a16="http://schemas.microsoft.com/office/drawing/2014/main" id="{08D6D268-BEE9-47C7-9AA4-38496737FDB6}"/>
+                <a16:creationId xmlns:a16="http://schemas.microsoft.com/office/drawing/2014/main" id="{781C6F8B-2AAA-4070-836C-3EF3DE8E3AFC}"/>
               </a:ext>
             </a:extLst>
           </p:cNvPr>
@@ -3805,7 +3805,7 @@
     </p:spTree>
     <p:extLst>
       <p:ext uri="{BB962C8B-B14F-4D97-AF65-F5344CB8AC3E}">
-        <p14:creationId xmlns:p14="http://schemas.microsoft.com/office/powerpoint/2010/main" val="1787031104"/>
+        <p14:creationId xmlns:p14="http://schemas.microsoft.com/office/powerpoint/2010/main" val="1264742548"/>
       </p:ext>
     </p:extLst>
   </p:cSld>
@@ -3836,7 +3836,7 @@
           <p:cNvPr id="11" name="">
             <a:extLst xmlns:a="http://schemas.openxmlformats.org/drawingml/2006/main">
               <a:ext uri="{FF2B5EF4-FFF2-40B4-BE49-F238E27FC236}">
-                <a16:creationId xmlns:a16="http://schemas.microsoft.com/office/drawing/2014/main" id="{B3223A05-3981-480E-B2E8-BB1535D3789D}"/>
+                <a16:creationId xmlns:a16="http://schemas.microsoft.com/office/drawing/2014/main" id="{8EB31363-1089-4A8E-91E9-E4AC8957EDD7}"/>
               </a:ext>
             </a:extLst>
           </p:cNvPr>
@@ -3893,7 +3893,7 @@
           <p:cNvPr id="2" name="">
             <a:extLst xmlns:a="http://schemas.openxmlformats.org/drawingml/2006/main">
               <a:ext uri="{FF2B5EF4-FFF2-40B4-BE49-F238E27FC236}">
-                <a16:creationId xmlns:a16="http://schemas.microsoft.com/office/drawing/2014/main" id="{B28538BB-23A6-4C9D-B4B1-C6616EB22F76}"/>
+                <a16:creationId xmlns:a16="http://schemas.microsoft.com/office/drawing/2014/main" id="{E71E4C6C-8992-4335-97E7-2FB6BB57EF76}"/>
               </a:ext>
             </a:extLst>
           </p:cNvPr>
@@ -3950,7 +3950,7 @@
           <p:cNvPr id="3" name="">
             <a:extLst xmlns:a="http://schemas.openxmlformats.org/drawingml/2006/main">
               <a:ext uri="{FF2B5EF4-FFF2-40B4-BE49-F238E27FC236}">
-                <a16:creationId xmlns:a16="http://schemas.microsoft.com/office/drawing/2014/main" id="{1D0B5385-B0D5-4FFB-B2F5-521FFFB31B07}"/>
+                <a16:creationId xmlns:a16="http://schemas.microsoft.com/office/drawing/2014/main" id="{D1DC5677-416D-4DF8-8A3C-AFA05C9DA791}"/>
               </a:ext>
             </a:extLst>
           </p:cNvPr>
@@ -4007,7 +4007,7 @@
           <p:cNvPr id="4" name="">
             <a:extLst xmlns:a="http://schemas.openxmlformats.org/drawingml/2006/main">
               <a:ext uri="{FF2B5EF4-FFF2-40B4-BE49-F238E27FC236}">
-                <a16:creationId xmlns:a16="http://schemas.microsoft.com/office/drawing/2014/main" id="{5577A250-8444-402E-B1F7-0FDE5C8CCA1E}"/>
+                <a16:creationId xmlns:a16="http://schemas.microsoft.com/office/drawing/2014/main" id="{6FB91E6F-39D5-4575-9B2A-F5E4964B0218}"/>
               </a:ext>
             </a:extLst>
           </p:cNvPr>
@@ -4064,7 +4064,7 @@
           <p:cNvPr id="5" name="">
             <a:extLst xmlns:a="http://schemas.openxmlformats.org/drawingml/2006/main">
               <a:ext uri="{FF2B5EF4-FFF2-40B4-BE49-F238E27FC236}">
-                <a16:creationId xmlns:a16="http://schemas.microsoft.com/office/drawing/2014/main" id="{51C9A630-DFC5-47BA-8A4D-1862BE575F5B}"/>
+                <a16:creationId xmlns:a16="http://schemas.microsoft.com/office/drawing/2014/main" id="{48CC5315-8E20-4833-B54E-2E46F18A7B2E}"/>
               </a:ext>
             </a:extLst>
           </p:cNvPr>
@@ -4121,7 +4121,7 @@
           <p:cNvPr id="6" name="">
             <a:extLst xmlns:a="http://schemas.openxmlformats.org/drawingml/2006/main">
               <a:ext uri="{FF2B5EF4-FFF2-40B4-BE49-F238E27FC236}">
-                <a16:creationId xmlns:a16="http://schemas.microsoft.com/office/drawing/2014/main" id="{257843E0-712D-4D45-8760-4BE9CA128894}"/>
+                <a16:creationId xmlns:a16="http://schemas.microsoft.com/office/drawing/2014/main" id="{0D681C76-EA3E-4EBE-B618-6A065E7C5903}"/>
               </a:ext>
             </a:extLst>
           </p:cNvPr>
@@ -4178,7 +4178,7 @@
           <p:cNvPr id="7" name="">
             <a:extLst xmlns:a="http://schemas.openxmlformats.org/drawingml/2006/main">
               <a:ext uri="{FF2B5EF4-FFF2-40B4-BE49-F238E27FC236}">
-                <a16:creationId xmlns:a16="http://schemas.microsoft.com/office/drawing/2014/main" id="{A69187DC-DEE8-4649-AE4B-AE51FEB3CDFC}"/>
+                <a16:creationId xmlns:a16="http://schemas.microsoft.com/office/drawing/2014/main" id="{28677858-F381-4EE2-A3C8-E31712D5956A}"/>
               </a:ext>
             </a:extLst>
           </p:cNvPr>
@@ -4235,7 +4235,7 @@
           <p:cNvPr id="8" name="">
             <a:extLst xmlns:a="http://schemas.openxmlformats.org/drawingml/2006/main">
               <a:ext uri="{FF2B5EF4-FFF2-40B4-BE49-F238E27FC236}">
-                <a16:creationId xmlns:a16="http://schemas.microsoft.com/office/drawing/2014/main" id="{62606321-EDA9-4FFB-B9E9-B35299051380}"/>
+                <a16:creationId xmlns:a16="http://schemas.microsoft.com/office/drawing/2014/main" id="{E33288E9-77B1-46F8-9AEE-157BA85A9296}"/>
               </a:ext>
             </a:extLst>
           </p:cNvPr>
@@ -4292,7 +4292,7 @@
           <p:cNvPr id="9" name="">
             <a:extLst xmlns:a="http://schemas.openxmlformats.org/drawingml/2006/main">
               <a:ext uri="{FF2B5EF4-FFF2-40B4-BE49-F238E27FC236}">
-                <a16:creationId xmlns:a16="http://schemas.microsoft.com/office/drawing/2014/main" id="{133056E0-5B17-43A4-81B6-2E387B66197B}"/>
+                <a16:creationId xmlns:a16="http://schemas.microsoft.com/office/drawing/2014/main" id="{D9C0F812-C4D9-44F3-B0A4-0137AF81AD76}"/>
               </a:ext>
             </a:extLst>
           </p:cNvPr>
@@ -4349,7 +4349,7 @@
           <p:cNvPr id="10" name="">
             <a:extLst xmlns:a="http://schemas.openxmlformats.org/drawingml/2006/main">
               <a:ext uri="{FF2B5EF4-FFF2-40B4-BE49-F238E27FC236}">
-                <a16:creationId xmlns:a16="http://schemas.microsoft.com/office/drawing/2014/main" id="{09715120-97AB-4AC1-AFB6-DC662146B233}"/>
+                <a16:creationId xmlns:a16="http://schemas.microsoft.com/office/drawing/2014/main" id="{1355F951-89F6-4CF3-AA10-7A31B5C5154C}"/>
               </a:ext>
             </a:extLst>
           </p:cNvPr>
@@ -4404,7 +4404,7 @@
     </p:spTree>
     <p:extLst>
       <p:ext uri="{BB962C8B-B14F-4D97-AF65-F5344CB8AC3E}">
-        <p14:creationId xmlns:p14="http://schemas.microsoft.com/office/powerpoint/2010/main" val="1700190253"/>
+        <p14:creationId xmlns:p14="http://schemas.microsoft.com/office/powerpoint/2010/main" val="2131103569"/>
       </p:ext>
     </p:extLst>
   </p:cSld>
@@ -4435,7 +4435,7 @@
           <p:cNvPr id="16" name="">
             <a:extLst xmlns:a="http://schemas.openxmlformats.org/drawingml/2006/main">
               <a:ext uri="{FF2B5EF4-FFF2-40B4-BE49-F238E27FC236}">
-                <a16:creationId xmlns:a16="http://schemas.microsoft.com/office/drawing/2014/main" id="{B868DC29-3DFE-4B25-8D36-AD7FD5327158}"/>
+                <a16:creationId xmlns:a16="http://schemas.microsoft.com/office/drawing/2014/main" id="{438D89AF-7517-44C2-BC05-2D834668D067}"/>
               </a:ext>
             </a:extLst>
           </p:cNvPr>
@@ -4492,7 +4492,7 @@
           <p:cNvPr id="2" name="">
             <a:extLst xmlns:a="http://schemas.openxmlformats.org/drawingml/2006/main">
               <a:ext uri="{FF2B5EF4-FFF2-40B4-BE49-F238E27FC236}">
-                <a16:creationId xmlns:a16="http://schemas.microsoft.com/office/drawing/2014/main" id="{A80064B9-FE10-4AF2-865A-9BEF481F3D68}"/>
+                <a16:creationId xmlns:a16="http://schemas.microsoft.com/office/drawing/2014/main" id="{9F70D6BE-91B3-4623-975B-5AD64B9E6F69}"/>
               </a:ext>
             </a:extLst>
           </p:cNvPr>
@@ -4549,7 +4549,7 @@
           <p:cNvPr id="3" name="">
             <a:extLst xmlns:a="http://schemas.openxmlformats.org/drawingml/2006/main">
               <a:ext uri="{FF2B5EF4-FFF2-40B4-BE49-F238E27FC236}">
-                <a16:creationId xmlns:a16="http://schemas.microsoft.com/office/drawing/2014/main" id="{599D4736-9599-448D-B6A3-9EC4262D24F9}"/>
+                <a16:creationId xmlns:a16="http://schemas.microsoft.com/office/drawing/2014/main" id="{EAF2B6FC-4AAA-4D0A-8115-5EC8B91B7C12}"/>
               </a:ext>
             </a:extLst>
           </p:cNvPr>
@@ -4606,7 +4606,7 @@
           <p:cNvPr id="4" name="">
             <a:extLst xmlns:a="http://schemas.openxmlformats.org/drawingml/2006/main">
               <a:ext uri="{FF2B5EF4-FFF2-40B4-BE49-F238E27FC236}">
-                <a16:creationId xmlns:a16="http://schemas.microsoft.com/office/drawing/2014/main" id="{DFBD4E38-5E8A-479A-9620-73244F8BAF00}"/>
+                <a16:creationId xmlns:a16="http://schemas.microsoft.com/office/drawing/2014/main" id="{934F3A2C-3262-4305-8075-74086F0309A6}"/>
               </a:ext>
             </a:extLst>
           </p:cNvPr>
@@ -4663,7 +4663,7 @@
           <p:cNvPr id="5" name="">
             <a:extLst xmlns:a="http://schemas.openxmlformats.org/drawingml/2006/main">
               <a:ext uri="{FF2B5EF4-FFF2-40B4-BE49-F238E27FC236}">
-                <a16:creationId xmlns:a16="http://schemas.microsoft.com/office/drawing/2014/main" id="{CF2A6059-D59A-4912-8ED6-BAEAD87EC4B5}"/>
+                <a16:creationId xmlns:a16="http://schemas.microsoft.com/office/drawing/2014/main" id="{21EFC794-4066-42E7-AC08-A2FB59A0692C}"/>
               </a:ext>
             </a:extLst>
           </p:cNvPr>
@@ -4720,7 +4720,7 @@
           <p:cNvPr id="6" name="">
             <a:extLst xmlns:a="http://schemas.openxmlformats.org/drawingml/2006/main">
               <a:ext uri="{FF2B5EF4-FFF2-40B4-BE49-F238E27FC236}">
-                <a16:creationId xmlns:a16="http://schemas.microsoft.com/office/drawing/2014/main" id="{28427790-6E6B-49E2-B93B-DC40E2045DAA}"/>
+                <a16:creationId xmlns:a16="http://schemas.microsoft.com/office/drawing/2014/main" id="{EC4F6A69-6134-417F-A0F7-B644CA9AD633}"/>
               </a:ext>
             </a:extLst>
           </p:cNvPr>
@@ -4777,7 +4777,7 @@
           <p:cNvPr id="7" name="">
             <a:extLst xmlns:a="http://schemas.openxmlformats.org/drawingml/2006/main">
               <a:ext uri="{FF2B5EF4-FFF2-40B4-BE49-F238E27FC236}">
-                <a16:creationId xmlns:a16="http://schemas.microsoft.com/office/drawing/2014/main" id="{24E68FD6-628A-41BF-ABE5-02B43DEB165C}"/>
+                <a16:creationId xmlns:a16="http://schemas.microsoft.com/office/drawing/2014/main" id="{503A8E77-1CCD-4563-BD94-AD3CB30CEAC4}"/>
               </a:ext>
             </a:extLst>
           </p:cNvPr>
@@ -4834,7 +4834,7 @@
           <p:cNvPr id="8" name="">
             <a:extLst xmlns:a="http://schemas.openxmlformats.org/drawingml/2006/main">
               <a:ext uri="{FF2B5EF4-FFF2-40B4-BE49-F238E27FC236}">
-                <a16:creationId xmlns:a16="http://schemas.microsoft.com/office/drawing/2014/main" id="{66F1FDDA-7EAB-402A-BC81-4A927AEFB704}"/>
+                <a16:creationId xmlns:a16="http://schemas.microsoft.com/office/drawing/2014/main" id="{1824D826-FED3-4C1A-B0EA-D5D101AD9E29}"/>
               </a:ext>
             </a:extLst>
           </p:cNvPr>
@@ -4891,7 +4891,7 @@
           <p:cNvPr id="9" name="">
             <a:extLst xmlns:a="http://schemas.openxmlformats.org/drawingml/2006/main">
               <a:ext uri="{FF2B5EF4-FFF2-40B4-BE49-F238E27FC236}">
-                <a16:creationId xmlns:a16="http://schemas.microsoft.com/office/drawing/2014/main" id="{6E0403AF-1EC2-440F-B48E-68D85E22C174}"/>
+                <a16:creationId xmlns:a16="http://schemas.microsoft.com/office/drawing/2014/main" id="{FEC574B5-BB1B-4FFD-8E6D-B6492221B922}"/>
               </a:ext>
             </a:extLst>
           </p:cNvPr>
@@ -4948,7 +4948,7 @@
           <p:cNvPr id="10" name="">
             <a:extLst xmlns:a="http://schemas.openxmlformats.org/drawingml/2006/main">
               <a:ext uri="{FF2B5EF4-FFF2-40B4-BE49-F238E27FC236}">
-                <a16:creationId xmlns:a16="http://schemas.microsoft.com/office/drawing/2014/main" id="{265FC871-1F1D-438E-A4A5-8D0FC3012268}"/>
+                <a16:creationId xmlns:a16="http://schemas.microsoft.com/office/drawing/2014/main" id="{B53B90FE-889F-41BF-9DFD-E8B5DC53C796}"/>
               </a:ext>
             </a:extLst>
           </p:cNvPr>
@@ -5005,7 +5005,7 @@
           <p:cNvPr id="11" name="">
             <a:extLst xmlns:a="http://schemas.openxmlformats.org/drawingml/2006/main">
               <a:ext uri="{FF2B5EF4-FFF2-40B4-BE49-F238E27FC236}">
-                <a16:creationId xmlns:a16="http://schemas.microsoft.com/office/drawing/2014/main" id="{183E135E-2839-4CF8-B151-B88F901785ED}"/>
+                <a16:creationId xmlns:a16="http://schemas.microsoft.com/office/drawing/2014/main" id="{28E6EE6D-F500-4748-BB84-B6F9936C86AC}"/>
               </a:ext>
             </a:extLst>
           </p:cNvPr>
@@ -5062,7 +5062,7 @@
           <p:cNvPr id="12" name="">
             <a:extLst xmlns:a="http://schemas.openxmlformats.org/drawingml/2006/main">
               <a:ext uri="{FF2B5EF4-FFF2-40B4-BE49-F238E27FC236}">
-                <a16:creationId xmlns:a16="http://schemas.microsoft.com/office/drawing/2014/main" id="{E7F0AA9F-D5D7-4364-94E5-8D980F813A9A}"/>
+                <a16:creationId xmlns:a16="http://schemas.microsoft.com/office/drawing/2014/main" id="{581A05EE-82A7-421A-B00F-2E4A655D99A5}"/>
               </a:ext>
             </a:extLst>
           </p:cNvPr>
@@ -5119,7 +5119,7 @@
           <p:cNvPr id="13" name="">
             <a:extLst xmlns:a="http://schemas.openxmlformats.org/drawingml/2006/main">
               <a:ext uri="{FF2B5EF4-FFF2-40B4-BE49-F238E27FC236}">
-                <a16:creationId xmlns:a16="http://schemas.microsoft.com/office/drawing/2014/main" id="{2CF93428-7988-439C-88FD-C86194CB335D}"/>
+                <a16:creationId xmlns:a16="http://schemas.microsoft.com/office/drawing/2014/main" id="{32621EE2-C872-46DE-82C2-C511F67C7BA6}"/>
               </a:ext>
             </a:extLst>
           </p:cNvPr>
@@ -5176,7 +5176,7 @@
           <p:cNvPr id="14" name="">
             <a:extLst xmlns:a="http://schemas.openxmlformats.org/drawingml/2006/main">
               <a:ext uri="{FF2B5EF4-FFF2-40B4-BE49-F238E27FC236}">
-                <a16:creationId xmlns:a16="http://schemas.microsoft.com/office/drawing/2014/main" id="{8F205B76-5E0C-4B7C-9518-6C4CD11D0CD5}"/>
+                <a16:creationId xmlns:a16="http://schemas.microsoft.com/office/drawing/2014/main" id="{E0704A2D-24AF-41C9-B012-9A5F13D4F001}"/>
               </a:ext>
             </a:extLst>
           </p:cNvPr>
@@ -5233,7 +5233,7 @@
           <p:cNvPr id="15" name="">
             <a:extLst xmlns:a="http://schemas.openxmlformats.org/drawingml/2006/main">
               <a:ext uri="{FF2B5EF4-FFF2-40B4-BE49-F238E27FC236}">
-                <a16:creationId xmlns:a16="http://schemas.microsoft.com/office/drawing/2014/main" id="{8EBA6303-243A-4CFA-B68F-D137ED42D723}"/>
+                <a16:creationId xmlns:a16="http://schemas.microsoft.com/office/drawing/2014/main" id="{77D80D3D-4EC9-4BC0-9272-C22D22AB8239}"/>
               </a:ext>
             </a:extLst>
           </p:cNvPr>
@@ -5288,7 +5288,7 @@
     </p:spTree>
     <p:extLst>
       <p:ext uri="{BB962C8B-B14F-4D97-AF65-F5344CB8AC3E}">
-        <p14:creationId xmlns:p14="http://schemas.microsoft.com/office/powerpoint/2010/main" val="1302399620"/>
+        <p14:creationId xmlns:p14="http://schemas.microsoft.com/office/powerpoint/2010/main" val="1299848433"/>
       </p:ext>
     </p:extLst>
   </p:cSld>
@@ -5319,7 +5319,7 @@
           <p:cNvPr id="7" name="">
             <a:extLst xmlns:a="http://schemas.openxmlformats.org/drawingml/2006/main">
               <a:ext uri="{FF2B5EF4-FFF2-40B4-BE49-F238E27FC236}">
-                <a16:creationId xmlns:a16="http://schemas.microsoft.com/office/drawing/2014/main" id="{F126A879-C256-4CCC-BB75-7777E233B506}"/>
+                <a16:creationId xmlns:a16="http://schemas.microsoft.com/office/drawing/2014/main" id="{D5F43DBE-2ABB-4F88-A1E1-D2D4C36B9D3A}"/>
               </a:ext>
             </a:extLst>
           </p:cNvPr>
@@ -5376,7 +5376,7 @@
           <p:cNvPr id="2" name="">
             <a:extLst xmlns:a="http://schemas.openxmlformats.org/drawingml/2006/main">
               <a:ext uri="{FF2B5EF4-FFF2-40B4-BE49-F238E27FC236}">
-                <a16:creationId xmlns:a16="http://schemas.microsoft.com/office/drawing/2014/main" id="{39F94C3B-DC2A-48C1-B1E1-66DF121B14E1}"/>
+                <a16:creationId xmlns:a16="http://schemas.microsoft.com/office/drawing/2014/main" id="{227869FF-16F3-4AFA-A757-B77558E483E5}"/>
               </a:ext>
             </a:extLst>
           </p:cNvPr>
@@ -5433,7 +5433,7 @@
           <p:cNvPr id="3" name="">
             <a:extLst xmlns:a="http://schemas.openxmlformats.org/drawingml/2006/main">
               <a:ext uri="{FF2B5EF4-FFF2-40B4-BE49-F238E27FC236}">
-                <a16:creationId xmlns:a16="http://schemas.microsoft.com/office/drawing/2014/main" id="{DEB8D60C-9635-4520-9165-7291D5ED8BA1}"/>
+                <a16:creationId xmlns:a16="http://schemas.microsoft.com/office/drawing/2014/main" id="{E77F4E77-CF76-459F-BD7B-B6F7054BCD83}"/>
               </a:ext>
             </a:extLst>
           </p:cNvPr>
@@ -5490,7 +5490,7 @@
           <p:cNvPr id="4" name="">
             <a:extLst xmlns:a="http://schemas.openxmlformats.org/drawingml/2006/main">
               <a:ext uri="{FF2B5EF4-FFF2-40B4-BE49-F238E27FC236}">
-                <a16:creationId xmlns:a16="http://schemas.microsoft.com/office/drawing/2014/main" id="{655FC5FE-9A61-41CC-8E0F-E254812E50D0}"/>
+                <a16:creationId xmlns:a16="http://schemas.microsoft.com/office/drawing/2014/main" id="{516C052F-45E9-4F76-8A0B-2AFAFA4F9DC2}"/>
               </a:ext>
             </a:extLst>
           </p:cNvPr>
@@ -5570,7 +5570,7 @@
           <p:cNvPr id="5" name="">
             <a:extLst xmlns:a="http://schemas.openxmlformats.org/drawingml/2006/main">
               <a:ext uri="{FF2B5EF4-FFF2-40B4-BE49-F238E27FC236}">
-                <a16:creationId xmlns:a16="http://schemas.microsoft.com/office/drawing/2014/main" id="{16E79BAF-A861-4318-A15D-A2AEE6D5E509}"/>
+                <a16:creationId xmlns:a16="http://schemas.microsoft.com/office/drawing/2014/main" id="{4D8544FA-27A7-44E9-BAA7-77C101461A44}"/>
               </a:ext>
             </a:extLst>
           </p:cNvPr>
@@ -5711,7 +5711,7 @@
           <p:cNvPr id="6" name="">
             <a:extLst xmlns:a="http://schemas.openxmlformats.org/drawingml/2006/main">
               <a:ext uri="{FF2B5EF4-FFF2-40B4-BE49-F238E27FC236}">
-                <a16:creationId xmlns:a16="http://schemas.microsoft.com/office/drawing/2014/main" id="{8E89D3AC-C391-4812-B29F-5CFB72B3272E}"/>
+                <a16:creationId xmlns:a16="http://schemas.microsoft.com/office/drawing/2014/main" id="{3CAC6BB5-C6B4-4A87-9FB6-D11694CD2513}"/>
               </a:ext>
             </a:extLst>
           </p:cNvPr>
@@ -5766,7 +5766,7 @@
     </p:spTree>
     <p:extLst>
       <p:ext uri="{BB962C8B-B14F-4D97-AF65-F5344CB8AC3E}">
-        <p14:creationId xmlns:p14="http://schemas.microsoft.com/office/powerpoint/2010/main" val="875281977"/>
+        <p14:creationId xmlns:p14="http://schemas.microsoft.com/office/powerpoint/2010/main" val="1575742430"/>
       </p:ext>
     </p:extLst>
   </p:cSld>
@@ -5797,7 +5797,7 @@
           <p:cNvPr id="20" name="">
             <a:extLst xmlns:a="http://schemas.openxmlformats.org/drawingml/2006/main">
               <a:ext uri="{FF2B5EF4-FFF2-40B4-BE49-F238E27FC236}">
-                <a16:creationId xmlns:a16="http://schemas.microsoft.com/office/drawing/2014/main" id="{12E560DF-B875-4D53-A2E0-AEEF0028E94D}"/>
+                <a16:creationId xmlns:a16="http://schemas.microsoft.com/office/drawing/2014/main" id="{BE99A75B-4DDA-45F6-AAB8-B515EB37410D}"/>
               </a:ext>
             </a:extLst>
           </p:cNvPr>
@@ -5854,7 +5854,7 @@
           <p:cNvPr id="2" name="">
             <a:extLst xmlns:a="http://schemas.openxmlformats.org/drawingml/2006/main">
               <a:ext uri="{FF2B5EF4-FFF2-40B4-BE49-F238E27FC236}">
-                <a16:creationId xmlns:a16="http://schemas.microsoft.com/office/drawing/2014/main" id="{5A50C7A5-7D4C-4AAC-872B-A7E209F68AAC}"/>
+                <a16:creationId xmlns:a16="http://schemas.microsoft.com/office/drawing/2014/main" id="{9F6C7D81-DC30-4D8C-BE14-98B5FB979B98}"/>
               </a:ext>
             </a:extLst>
           </p:cNvPr>
@@ -5911,7 +5911,7 @@
           <p:cNvPr id="3" name="">
             <a:extLst xmlns:a="http://schemas.openxmlformats.org/drawingml/2006/main">
               <a:ext uri="{FF2B5EF4-FFF2-40B4-BE49-F238E27FC236}">
-                <a16:creationId xmlns:a16="http://schemas.microsoft.com/office/drawing/2014/main" id="{B517E0B0-FDA4-42D9-9533-87DA0B98B362}"/>
+                <a16:creationId xmlns:a16="http://schemas.microsoft.com/office/drawing/2014/main" id="{7F3B21DD-094A-4B29-853B-52500D98F4BE}"/>
               </a:ext>
             </a:extLst>
           </p:cNvPr>
@@ -5943,7 +5943,7 @@
           <p:cNvPr id="4" name="">
             <a:extLst xmlns:a="http://schemas.openxmlformats.org/drawingml/2006/main">
               <a:ext uri="{FF2B5EF4-FFF2-40B4-BE49-F238E27FC236}">
-                <a16:creationId xmlns:a16="http://schemas.microsoft.com/office/drawing/2014/main" id="{50D8D858-DD74-49E8-9453-A1E62A5086EC}"/>
+                <a16:creationId xmlns:a16="http://schemas.microsoft.com/office/drawing/2014/main" id="{1B73010F-C3BD-456B-A31F-95B4B9E02B68}"/>
               </a:ext>
             </a:extLst>
           </p:cNvPr>
@@ -6000,7 +6000,7 @@
           <p:cNvPr id="5" name="">
             <a:extLst xmlns:a="http://schemas.openxmlformats.org/drawingml/2006/main">
               <a:ext uri="{FF2B5EF4-FFF2-40B4-BE49-F238E27FC236}">
-                <a16:creationId xmlns:a16="http://schemas.microsoft.com/office/drawing/2014/main" id="{37725826-BD96-4C46-B11C-1BAF3F5C8FBF}"/>
+                <a16:creationId xmlns:a16="http://schemas.microsoft.com/office/drawing/2014/main" id="{A757E42C-C1B7-4BCA-820D-3E2B4C5AAF58}"/>
               </a:ext>
             </a:extLst>
           </p:cNvPr>
@@ -6057,7 +6057,7 @@
           <p:cNvPr id="6" name="">
             <a:extLst xmlns:a="http://schemas.openxmlformats.org/drawingml/2006/main">
               <a:ext uri="{FF2B5EF4-FFF2-40B4-BE49-F238E27FC236}">
-                <a16:creationId xmlns:a16="http://schemas.microsoft.com/office/drawing/2014/main" id="{9674DC50-AE55-4670-AE94-79A80EB8BEB3}"/>
+                <a16:creationId xmlns:a16="http://schemas.microsoft.com/office/drawing/2014/main" id="{CD9591CB-DC8E-41D0-A2A5-E505FF22DAD1}"/>
               </a:ext>
             </a:extLst>
           </p:cNvPr>
@@ -6089,7 +6089,7 @@
           <p:cNvPr id="7" name="">
             <a:extLst xmlns:a="http://schemas.openxmlformats.org/drawingml/2006/main">
               <a:ext uri="{FF2B5EF4-FFF2-40B4-BE49-F238E27FC236}">
-                <a16:creationId xmlns:a16="http://schemas.microsoft.com/office/drawing/2014/main" id="{FA19D179-CE1A-425A-B7CA-599B688F3F7E}"/>
+                <a16:creationId xmlns:a16="http://schemas.microsoft.com/office/drawing/2014/main" id="{6419D883-CA52-410A-A078-FC5E418AA48D}"/>
               </a:ext>
             </a:extLst>
           </p:cNvPr>
@@ -6146,7 +6146,7 @@
           <p:cNvPr id="8" name="">
             <a:extLst xmlns:a="http://schemas.openxmlformats.org/drawingml/2006/main">
               <a:ext uri="{FF2B5EF4-FFF2-40B4-BE49-F238E27FC236}">
-                <a16:creationId xmlns:a16="http://schemas.microsoft.com/office/drawing/2014/main" id="{8702A4E8-7761-421A-B707-B5EFAF943097}"/>
+                <a16:creationId xmlns:a16="http://schemas.microsoft.com/office/drawing/2014/main" id="{4A5BF3B9-FF0C-4108-B4C3-AE655E7D4A5B}"/>
               </a:ext>
             </a:extLst>
           </p:cNvPr>
@@ -6203,7 +6203,7 @@
           <p:cNvPr id="9" name="">
             <a:extLst xmlns:a="http://schemas.openxmlformats.org/drawingml/2006/main">
               <a:ext uri="{FF2B5EF4-FFF2-40B4-BE49-F238E27FC236}">
-                <a16:creationId xmlns:a16="http://schemas.microsoft.com/office/drawing/2014/main" id="{3898845D-1D4F-43F5-A1F7-1C90FF1DB35F}"/>
+                <a16:creationId xmlns:a16="http://schemas.microsoft.com/office/drawing/2014/main" id="{0B121B19-2DEB-450F-86F2-F3C2B030F1F6}"/>
               </a:ext>
             </a:extLst>
           </p:cNvPr>
@@ -6235,7 +6235,7 @@
           <p:cNvPr id="10" name="">
             <a:extLst xmlns:a="http://schemas.openxmlformats.org/drawingml/2006/main">
               <a:ext uri="{FF2B5EF4-FFF2-40B4-BE49-F238E27FC236}">
-                <a16:creationId xmlns:a16="http://schemas.microsoft.com/office/drawing/2014/main" id="{315428DA-232A-49EA-BC75-DD1F38CA06F8}"/>
+                <a16:creationId xmlns:a16="http://schemas.microsoft.com/office/drawing/2014/main" id="{15240F6A-561C-4E55-ABF3-0359D8904BAD}"/>
               </a:ext>
             </a:extLst>
           </p:cNvPr>
@@ -6292,7 +6292,7 @@
           <p:cNvPr id="11" name="">
             <a:extLst xmlns:a="http://schemas.openxmlformats.org/drawingml/2006/main">
               <a:ext uri="{FF2B5EF4-FFF2-40B4-BE49-F238E27FC236}">
-                <a16:creationId xmlns:a16="http://schemas.microsoft.com/office/drawing/2014/main" id="{04D98F59-8A30-4A06-B844-831DA5264157}"/>
+                <a16:creationId xmlns:a16="http://schemas.microsoft.com/office/drawing/2014/main" id="{A720A4D7-1BA1-4E7A-A588-3103ADC90291}"/>
               </a:ext>
             </a:extLst>
           </p:cNvPr>
@@ -6349,7 +6349,7 @@
           <p:cNvPr id="12" name="">
             <a:extLst xmlns:a="http://schemas.openxmlformats.org/drawingml/2006/main">
               <a:ext uri="{FF2B5EF4-FFF2-40B4-BE49-F238E27FC236}">
-                <a16:creationId xmlns:a16="http://schemas.microsoft.com/office/drawing/2014/main" id="{784CB378-C8A2-4197-BB18-0BB082E71F4E}"/>
+                <a16:creationId xmlns:a16="http://schemas.microsoft.com/office/drawing/2014/main" id="{37FFCC03-4AF4-46C2-A5FD-BA52FFB09688}"/>
               </a:ext>
             </a:extLst>
           </p:cNvPr>
@@ -6381,7 +6381,7 @@
           <p:cNvPr id="13" name="">
             <a:extLst xmlns:a="http://schemas.openxmlformats.org/drawingml/2006/main">
               <a:ext uri="{FF2B5EF4-FFF2-40B4-BE49-F238E27FC236}">
-                <a16:creationId xmlns:a16="http://schemas.microsoft.com/office/drawing/2014/main" id="{46825BED-38B9-46A4-AA9A-DC6D577FD499}"/>
+                <a16:creationId xmlns:a16="http://schemas.microsoft.com/office/drawing/2014/main" id="{EF5A20DB-E746-4159-8508-B66C87B82F51}"/>
               </a:ext>
             </a:extLst>
           </p:cNvPr>
@@ -6438,7 +6438,7 @@
           <p:cNvPr id="14" name="">
             <a:extLst xmlns:a="http://schemas.openxmlformats.org/drawingml/2006/main">
               <a:ext uri="{FF2B5EF4-FFF2-40B4-BE49-F238E27FC236}">
-                <a16:creationId xmlns:a16="http://schemas.microsoft.com/office/drawing/2014/main" id="{7D32573A-BC58-4113-9AE5-2F13B139E3D7}"/>
+                <a16:creationId xmlns:a16="http://schemas.microsoft.com/office/drawing/2014/main" id="{40383BE1-6047-449C-8171-F0FD482F6F30}"/>
               </a:ext>
             </a:extLst>
           </p:cNvPr>
@@ -6570,7 +6570,7 @@
           <p:cNvPr id="18" name="">
             <a:extLst xmlns:a="http://schemas.openxmlformats.org/drawingml/2006/main">
               <a:ext uri="{FF2B5EF4-FFF2-40B4-BE49-F238E27FC236}">
-                <a16:creationId xmlns:a16="http://schemas.microsoft.com/office/drawing/2014/main" id="{D808ABD1-883E-401C-9C92-EFFF18F19F33}"/>
+                <a16:creationId xmlns:a16="http://schemas.microsoft.com/office/drawing/2014/main" id="{03B51C2F-ECE6-4C9F-B90B-534F07768196}"/>
               </a:ext>
             </a:extLst>
           </p:cNvPr>
@@ -6627,7 +6627,7 @@
           <p:cNvPr id="19" name="">
             <a:extLst xmlns:a="http://schemas.openxmlformats.org/drawingml/2006/main">
               <a:ext uri="{FF2B5EF4-FFF2-40B4-BE49-F238E27FC236}">
-                <a16:creationId xmlns:a16="http://schemas.microsoft.com/office/drawing/2014/main" id="{41D6B575-0591-4637-80AF-158E4C020B85}"/>
+                <a16:creationId xmlns:a16="http://schemas.microsoft.com/office/drawing/2014/main" id="{751A31D3-9C38-4FCF-A0DA-6F26D653EDCE}"/>
               </a:ext>
             </a:extLst>
           </p:cNvPr>
@@ -6682,7 +6682,7 @@
     </p:spTree>
     <p:extLst>
       <p:ext uri="{BB962C8B-B14F-4D97-AF65-F5344CB8AC3E}">
-        <p14:creationId xmlns:p14="http://schemas.microsoft.com/office/powerpoint/2010/main" val="481132202"/>
+        <p14:creationId xmlns:p14="http://schemas.microsoft.com/office/powerpoint/2010/main" val="616553512"/>
       </p:ext>
     </p:extLst>
   </p:cSld>
@@ -6713,7 +6713,7 @@
           <p:cNvPr id="11" name="">
             <a:extLst xmlns:a="http://schemas.openxmlformats.org/drawingml/2006/main">
               <a:ext uri="{FF2B5EF4-FFF2-40B4-BE49-F238E27FC236}">
-                <a16:creationId xmlns:a16="http://schemas.microsoft.com/office/drawing/2014/main" id="{5EE98587-8577-478C-B21C-19D2CC5AB934}"/>
+                <a16:creationId xmlns:a16="http://schemas.microsoft.com/office/drawing/2014/main" id="{5A8EDC21-39B1-4CD7-9424-307AD0736EEA}"/>
               </a:ext>
             </a:extLst>
           </p:cNvPr>
@@ -6770,7 +6770,7 @@
           <p:cNvPr id="2" name="">
             <a:extLst xmlns:a="http://schemas.openxmlformats.org/drawingml/2006/main">
               <a:ext uri="{FF2B5EF4-FFF2-40B4-BE49-F238E27FC236}">
-                <a16:creationId xmlns:a16="http://schemas.microsoft.com/office/drawing/2014/main" id="{719C5161-B9F2-4BC2-B6EB-209515D6B25C}"/>
+                <a16:creationId xmlns:a16="http://schemas.microsoft.com/office/drawing/2014/main" id="{B34BB5DC-4BFC-4CC8-92FE-B83FAF1BE533}"/>
               </a:ext>
             </a:extLst>
           </p:cNvPr>
@@ -6827,7 +6827,7 @@
           <p:cNvPr id="3" name="">
             <a:extLst xmlns:a="http://schemas.openxmlformats.org/drawingml/2006/main">
               <a:ext uri="{FF2B5EF4-FFF2-40B4-BE49-F238E27FC236}">
-                <a16:creationId xmlns:a16="http://schemas.microsoft.com/office/drawing/2014/main" id="{0972378B-5F18-4F4A-B5EB-EE3010A5D45B}"/>
+                <a16:creationId xmlns:a16="http://schemas.microsoft.com/office/drawing/2014/main" id="{AE8D025C-DE44-455F-B301-7E4C31EA112E}"/>
               </a:ext>
             </a:extLst>
           </p:cNvPr>
@@ -6884,7 +6884,7 @@
           <p:cNvPr id="4" name="">
             <a:extLst xmlns:a="http://schemas.openxmlformats.org/drawingml/2006/main">
               <a:ext uri="{FF2B5EF4-FFF2-40B4-BE49-F238E27FC236}">
-                <a16:creationId xmlns:a16="http://schemas.microsoft.com/office/drawing/2014/main" id="{B49C35F8-F725-4521-A5E2-E48C89D48E20}"/>
+                <a16:creationId xmlns:a16="http://schemas.microsoft.com/office/drawing/2014/main" id="{C6DBBF9B-663E-4620-AC13-AA3A0FB3536C}"/>
               </a:ext>
             </a:extLst>
           </p:cNvPr>
@@ -6941,7 +6941,7 @@
           <p:cNvPr id="5" name="">
             <a:extLst xmlns:a="http://schemas.openxmlformats.org/drawingml/2006/main">
               <a:ext uri="{FF2B5EF4-FFF2-40B4-BE49-F238E27FC236}">
-                <a16:creationId xmlns:a16="http://schemas.microsoft.com/office/drawing/2014/main" id="{93A806A6-7B98-42BB-B529-416C7AAFBBA9}"/>
+                <a16:creationId xmlns:a16="http://schemas.microsoft.com/office/drawing/2014/main" id="{27DFD33C-A050-4C2F-A5D4-E92197F90C3F}"/>
               </a:ext>
             </a:extLst>
           </p:cNvPr>
@@ -6998,7 +6998,7 @@
           <p:cNvPr id="6" name="">
             <a:extLst xmlns:a="http://schemas.openxmlformats.org/drawingml/2006/main">
               <a:ext uri="{FF2B5EF4-FFF2-40B4-BE49-F238E27FC236}">
-                <a16:creationId xmlns:a16="http://schemas.microsoft.com/office/drawing/2014/main" id="{F37CF5F4-C8DB-4CEF-975C-957EA07CED40}"/>
+                <a16:creationId xmlns:a16="http://schemas.microsoft.com/office/drawing/2014/main" id="{7E49762E-7444-4B66-96CA-2DD20F02E6CF}"/>
               </a:ext>
             </a:extLst>
           </p:cNvPr>
@@ -7055,7 +7055,7 @@
           <p:cNvPr id="7" name="">
             <a:extLst xmlns:a="http://schemas.openxmlformats.org/drawingml/2006/main">
               <a:ext uri="{FF2B5EF4-FFF2-40B4-BE49-F238E27FC236}">
-                <a16:creationId xmlns:a16="http://schemas.microsoft.com/office/drawing/2014/main" id="{EFE3406F-FFC5-4CD2-B89D-8776E2987061}"/>
+                <a16:creationId xmlns:a16="http://schemas.microsoft.com/office/drawing/2014/main" id="{8F7B9632-6EBB-4855-ADD2-78C1DCD00A3A}"/>
               </a:ext>
             </a:extLst>
           </p:cNvPr>
@@ -7112,7 +7112,7 @@
           <p:cNvPr id="8" name="">
             <a:extLst xmlns:a="http://schemas.openxmlformats.org/drawingml/2006/main">
               <a:ext uri="{FF2B5EF4-FFF2-40B4-BE49-F238E27FC236}">
-                <a16:creationId xmlns:a16="http://schemas.microsoft.com/office/drawing/2014/main" id="{A9E87D75-263C-4170-8489-DD3AE0EE900C}"/>
+                <a16:creationId xmlns:a16="http://schemas.microsoft.com/office/drawing/2014/main" id="{4B400C02-A6DF-499D-8E85-6530FEE26CE5}"/>
               </a:ext>
             </a:extLst>
           </p:cNvPr>
@@ -7169,7 +7169,7 @@
           <p:cNvPr id="9" name="">
             <a:extLst xmlns:a="http://schemas.openxmlformats.org/drawingml/2006/main">
               <a:ext uri="{FF2B5EF4-FFF2-40B4-BE49-F238E27FC236}">
-                <a16:creationId xmlns:a16="http://schemas.microsoft.com/office/drawing/2014/main" id="{15490553-F3A2-4D74-B8B7-E70C3A7E45DB}"/>
+                <a16:creationId xmlns:a16="http://schemas.microsoft.com/office/drawing/2014/main" id="{2F551980-F2FF-4A36-8B02-DDFD87993962}"/>
               </a:ext>
             </a:extLst>
           </p:cNvPr>
@@ -7226,7 +7226,7 @@
           <p:cNvPr id="10" name="">
             <a:extLst xmlns:a="http://schemas.openxmlformats.org/drawingml/2006/main">
               <a:ext uri="{FF2B5EF4-FFF2-40B4-BE49-F238E27FC236}">
-                <a16:creationId xmlns:a16="http://schemas.microsoft.com/office/drawing/2014/main" id="{1870A752-EE11-49AC-B84A-0CA759A4C64B}"/>
+                <a16:creationId xmlns:a16="http://schemas.microsoft.com/office/drawing/2014/main" id="{BB0D3554-7361-45C8-BC06-249905C47082}"/>
               </a:ext>
             </a:extLst>
           </p:cNvPr>
@@ -7281,7 +7281,7 @@
     </p:spTree>
     <p:extLst>
       <p:ext uri="{BB962C8B-B14F-4D97-AF65-F5344CB8AC3E}">
-        <p14:creationId xmlns:p14="http://schemas.microsoft.com/office/powerpoint/2010/main" val="600672372"/>
+        <p14:creationId xmlns:p14="http://schemas.microsoft.com/office/powerpoint/2010/main" val="2068614278"/>
       </p:ext>
     </p:extLst>
   </p:cSld>
@@ -7312,7 +7312,7 @@
           <p:cNvPr id="11" name="">
             <a:extLst xmlns:a="http://schemas.openxmlformats.org/drawingml/2006/main">
               <a:ext uri="{FF2B5EF4-FFF2-40B4-BE49-F238E27FC236}">
-                <a16:creationId xmlns:a16="http://schemas.microsoft.com/office/drawing/2014/main" id="{41876C15-0580-4BE8-B95A-C275E7B3B60B}"/>
+                <a16:creationId xmlns:a16="http://schemas.microsoft.com/office/drawing/2014/main" id="{D02D7D9B-D740-41E8-ADAC-98601D766B7C}"/>
               </a:ext>
             </a:extLst>
           </p:cNvPr>
@@ -7369,7 +7369,7 @@
           <p:cNvPr id="2" name="">
             <a:extLst xmlns:a="http://schemas.openxmlformats.org/drawingml/2006/main">
               <a:ext uri="{FF2B5EF4-FFF2-40B4-BE49-F238E27FC236}">
-                <a16:creationId xmlns:a16="http://schemas.microsoft.com/office/drawing/2014/main" id="{EA73398E-10F4-4DC8-8AE3-363D6D6A6C12}"/>
+                <a16:creationId xmlns:a16="http://schemas.microsoft.com/office/drawing/2014/main" id="{B94582E8-B904-44FF-BCA6-36D2B81475A9}"/>
               </a:ext>
             </a:extLst>
           </p:cNvPr>
@@ -7426,7 +7426,7 @@
           <p:cNvPr id="3" name="">
             <a:extLst xmlns:a="http://schemas.openxmlformats.org/drawingml/2006/main">
               <a:ext uri="{FF2B5EF4-FFF2-40B4-BE49-F238E27FC236}">
-                <a16:creationId xmlns:a16="http://schemas.microsoft.com/office/drawing/2014/main" id="{6E07585F-FC7D-43E0-87AC-96D43D98E657}"/>
+                <a16:creationId xmlns:a16="http://schemas.microsoft.com/office/drawing/2014/main" id="{2131FCA8-9F7B-46FA-8128-C64E2BE01996}"/>
               </a:ext>
             </a:extLst>
           </p:cNvPr>
@@ -7473,7 +7473,7 @@
                 <a:ea typeface="DejaVu Sans"/>
                 <a:cs typeface="DejaVu Sans"/>
               </a:rPr>
-              <a:t>Validado localmente</a:t>
+              <a:t>Demo publicada</a:t>
             </a:r>
           </a:p>
         </p:txBody>
@@ -7483,7 +7483,7 @@
           <p:cNvPr id="4" name="">
             <a:extLst xmlns:a="http://schemas.openxmlformats.org/drawingml/2006/main">
               <a:ext uri="{FF2B5EF4-FFF2-40B4-BE49-F238E27FC236}">
-                <a16:creationId xmlns:a16="http://schemas.microsoft.com/office/drawing/2014/main" id="{D4B7E3FE-7BE5-47BB-BD19-65E38731E66D}"/>
+                <a16:creationId xmlns:a16="http://schemas.microsoft.com/office/drawing/2014/main" id="{95685806-2D51-49D5-B31C-56E0F6E651D0}"/>
               </a:ext>
             </a:extLst>
           </p:cNvPr>
@@ -7530,7 +7530,7 @@
                 <a:ea typeface="DejaVu Sans"/>
                 <a:cs typeface="DejaVu Sans"/>
               </a:rPr>
-              <a:t>Flujos principales, controles, reportes y API.</a:t>
+              <a:t>Render y Neon: HTTPS, roles, inventario y tickets.</a:t>
             </a:r>
           </a:p>
         </p:txBody>
@@ -7540,7 +7540,7 @@
           <p:cNvPr id="5" name="">
             <a:extLst xmlns:a="http://schemas.openxmlformats.org/drawingml/2006/main">
               <a:ext uri="{FF2B5EF4-FFF2-40B4-BE49-F238E27FC236}">
-                <a16:creationId xmlns:a16="http://schemas.microsoft.com/office/drawing/2014/main" id="{77905AF2-C866-4A60-990F-668C894122A8}"/>
+                <a16:creationId xmlns:a16="http://schemas.microsoft.com/office/drawing/2014/main" id="{5A74D299-C7D8-4BEA-ADFF-C59AAF576DC2}"/>
               </a:ext>
             </a:extLst>
           </p:cNvPr>
@@ -7597,7 +7597,7 @@
           <p:cNvPr id="6" name="">
             <a:extLst xmlns:a="http://schemas.openxmlformats.org/drawingml/2006/main">
               <a:ext uri="{FF2B5EF4-FFF2-40B4-BE49-F238E27FC236}">
-                <a16:creationId xmlns:a16="http://schemas.microsoft.com/office/drawing/2014/main" id="{2EDF3474-1981-42B3-A4B9-88D6172E42E9}"/>
+                <a16:creationId xmlns:a16="http://schemas.microsoft.com/office/drawing/2014/main" id="{C5F9E075-70DF-4264-98E1-F000C22FE6A4}"/>
               </a:ext>
             </a:extLst>
           </p:cNvPr>
@@ -7654,7 +7654,7 @@
           <p:cNvPr id="7" name="">
             <a:extLst xmlns:a="http://schemas.openxmlformats.org/drawingml/2006/main">
               <a:ext uri="{FF2B5EF4-FFF2-40B4-BE49-F238E27FC236}">
-                <a16:creationId xmlns:a16="http://schemas.microsoft.com/office/drawing/2014/main" id="{AED8D7C5-B0F9-4AD8-989B-8184237DC292}"/>
+                <a16:creationId xmlns:a16="http://schemas.microsoft.com/office/drawing/2014/main" id="{E95870B9-6B65-4F3D-A91E-6442C7C0572D}"/>
               </a:ext>
             </a:extLst>
           </p:cNvPr>
@@ -7701,7 +7701,7 @@
                 <a:ea typeface="DejaVu Sans"/>
                 <a:cs typeface="DejaVu Sans"/>
               </a:rPr>
-              <a:t>Pendiente de despliegue</a:t>
+              <a:t>Pendiente operativo</a:t>
             </a:r>
           </a:p>
         </p:txBody>
@@ -7711,7 +7711,7 @@
           <p:cNvPr id="8" name="">
             <a:extLst xmlns:a="http://schemas.openxmlformats.org/drawingml/2006/main">
               <a:ext uri="{FF2B5EF4-FFF2-40B4-BE49-F238E27FC236}">
-                <a16:creationId xmlns:a16="http://schemas.microsoft.com/office/drawing/2014/main" id="{6C59EDE0-D48D-42D9-BDCB-2B6BE2AE2857}"/>
+                <a16:creationId xmlns:a16="http://schemas.microsoft.com/office/drawing/2014/main" id="{827991F8-5C75-472A-A172-DDC174E744E6}"/>
               </a:ext>
             </a:extLst>
           </p:cNvPr>
@@ -7758,7 +7758,7 @@
                 <a:ea typeface="DejaVu Sans"/>
                 <a:cs typeface="DejaVu Sans"/>
               </a:rPr>
-              <a:t>HTTPS, cifrado en reposo, respaldo y operación.</a:t>
+              <a:t>Cifrado en reposo, respaldo y restauración.</a:t>
             </a:r>
           </a:p>
         </p:txBody>
@@ -7768,7 +7768,7 @@
           <p:cNvPr id="9" name="">
             <a:extLst xmlns:a="http://schemas.openxmlformats.org/drawingml/2006/main">
               <a:ext uri="{FF2B5EF4-FFF2-40B4-BE49-F238E27FC236}">
-                <a16:creationId xmlns:a16="http://schemas.microsoft.com/office/drawing/2014/main" id="{FCF08B66-7706-4248-904A-3B9DE7BC1B38}"/>
+                <a16:creationId xmlns:a16="http://schemas.microsoft.com/office/drawing/2014/main" id="{9264133E-004D-4798-9E7E-2BF25D4BDB4D}"/>
               </a:ext>
             </a:extLst>
           </p:cNvPr>
@@ -7825,7 +7825,7 @@
           <p:cNvPr id="10" name="">
             <a:extLst xmlns:a="http://schemas.openxmlformats.org/drawingml/2006/main">
               <a:ext uri="{FF2B5EF4-FFF2-40B4-BE49-F238E27FC236}">
-                <a16:creationId xmlns:a16="http://schemas.microsoft.com/office/drawing/2014/main" id="{CBA7AC71-1192-49A7-9A77-FBFA1636B876}"/>
+                <a16:creationId xmlns:a16="http://schemas.microsoft.com/office/drawing/2014/main" id="{04FB5DF8-4A0B-424C-808E-7BD982447D3B}"/>
               </a:ext>
             </a:extLst>
           </p:cNvPr>
@@ -7880,7 +7880,7 @@
     </p:spTree>
     <p:extLst>
       <p:ext uri="{BB962C8B-B14F-4D97-AF65-F5344CB8AC3E}">
-        <p14:creationId xmlns:p14="http://schemas.microsoft.com/office/powerpoint/2010/main" val="628294963"/>
+        <p14:creationId xmlns:p14="http://schemas.microsoft.com/office/powerpoint/2010/main" val="1001949896"/>
       </p:ext>
     </p:extLst>
   </p:cSld>
@@ -7911,7 +7911,7 @@
           <p:cNvPr id="5" name="">
             <a:extLst xmlns:a="http://schemas.openxmlformats.org/drawingml/2006/main">
               <a:ext uri="{FF2B5EF4-FFF2-40B4-BE49-F238E27FC236}">
-                <a16:creationId xmlns:a16="http://schemas.microsoft.com/office/drawing/2014/main" id="{0D122C25-32D8-44C9-B721-D32B7BA78832}"/>
+                <a16:creationId xmlns:a16="http://schemas.microsoft.com/office/drawing/2014/main" id="{33C33936-2CE3-4143-8CD1-C6D7E672D913}"/>
               </a:ext>
             </a:extLst>
           </p:cNvPr>
@@ -7968,7 +7968,7 @@
           <p:cNvPr id="2" name="">
             <a:extLst xmlns:a="http://schemas.openxmlformats.org/drawingml/2006/main">
               <a:ext uri="{FF2B5EF4-FFF2-40B4-BE49-F238E27FC236}">
-                <a16:creationId xmlns:a16="http://schemas.microsoft.com/office/drawing/2014/main" id="{29D0C742-5A8C-46D7-9064-3000174B14A0}"/>
+                <a16:creationId xmlns:a16="http://schemas.microsoft.com/office/drawing/2014/main" id="{41848344-9959-4CAE-8830-E68C74791751}"/>
               </a:ext>
             </a:extLst>
           </p:cNvPr>
@@ -8025,7 +8025,7 @@
           <p:cNvPr id="3" name="">
             <a:extLst xmlns:a="http://schemas.openxmlformats.org/drawingml/2006/main">
               <a:ext uri="{FF2B5EF4-FFF2-40B4-BE49-F238E27FC236}">
-                <a16:creationId xmlns:a16="http://schemas.microsoft.com/office/drawing/2014/main" id="{2A20390D-0CC9-4F37-BE69-A7B54E880504}"/>
+                <a16:creationId xmlns:a16="http://schemas.microsoft.com/office/drawing/2014/main" id="{BE23F8FB-0939-4592-B285-354C8B31C188}"/>
               </a:ext>
             </a:extLst>
           </p:cNvPr>
@@ -8105,7 +8105,7 @@
           <p:cNvPr id="4" name="">
             <a:extLst xmlns:a="http://schemas.openxmlformats.org/drawingml/2006/main">
               <a:ext uri="{FF2B5EF4-FFF2-40B4-BE49-F238E27FC236}">
-                <a16:creationId xmlns:a16="http://schemas.microsoft.com/office/drawing/2014/main" id="{2BA5FAEE-D265-4156-A0B6-FF926280D3C3}"/>
+                <a16:creationId xmlns:a16="http://schemas.microsoft.com/office/drawing/2014/main" id="{7CDDC504-728E-4D69-8358-55FC69A60E42}"/>
               </a:ext>
             </a:extLst>
           </p:cNvPr>
@@ -8160,7 +8160,7 @@
     </p:spTree>
     <p:extLst>
       <p:ext uri="{BB962C8B-B14F-4D97-AF65-F5344CB8AC3E}">
-        <p14:creationId xmlns:p14="http://schemas.microsoft.com/office/powerpoint/2010/main" val="7873805"/>
+        <p14:creationId xmlns:p14="http://schemas.microsoft.com/office/powerpoint/2010/main" val="806823905"/>
       </p:ext>
     </p:extLst>
   </p:cSld>
@@ -8191,7 +8191,7 @@
           <p:cNvPr id="11" name="">
             <a:extLst xmlns:a="http://schemas.openxmlformats.org/drawingml/2006/main">
               <a:ext uri="{FF2B5EF4-FFF2-40B4-BE49-F238E27FC236}">
-                <a16:creationId xmlns:a16="http://schemas.microsoft.com/office/drawing/2014/main" id="{88BC30F8-EFC5-4740-A0D5-F58EF14FD266}"/>
+                <a16:creationId xmlns:a16="http://schemas.microsoft.com/office/drawing/2014/main" id="{345EDB30-A83A-404C-B853-7B314204B1DF}"/>
               </a:ext>
             </a:extLst>
           </p:cNvPr>
@@ -8248,7 +8248,7 @@
           <p:cNvPr id="2" name="">
             <a:extLst xmlns:a="http://schemas.openxmlformats.org/drawingml/2006/main">
               <a:ext uri="{FF2B5EF4-FFF2-40B4-BE49-F238E27FC236}">
-                <a16:creationId xmlns:a16="http://schemas.microsoft.com/office/drawing/2014/main" id="{53B5B214-F7B9-4DD3-8426-561A9FCD3E13}"/>
+                <a16:creationId xmlns:a16="http://schemas.microsoft.com/office/drawing/2014/main" id="{C903D633-E1E3-46AD-8680-A1690E15145B}"/>
               </a:ext>
             </a:extLst>
           </p:cNvPr>
@@ -8305,7 +8305,7 @@
           <p:cNvPr id="3" name="">
             <a:extLst xmlns:a="http://schemas.openxmlformats.org/drawingml/2006/main">
               <a:ext uri="{FF2B5EF4-FFF2-40B4-BE49-F238E27FC236}">
-                <a16:creationId xmlns:a16="http://schemas.microsoft.com/office/drawing/2014/main" id="{782FE156-4D6E-4AD2-BE1A-FDBA18F3885E}"/>
+                <a16:creationId xmlns:a16="http://schemas.microsoft.com/office/drawing/2014/main" id="{D8A0A183-A787-4369-B20F-54C398EF7466}"/>
               </a:ext>
             </a:extLst>
           </p:cNvPr>
@@ -8362,7 +8362,7 @@
           <p:cNvPr id="4" name="">
             <a:extLst xmlns:a="http://schemas.openxmlformats.org/drawingml/2006/main">
               <a:ext uri="{FF2B5EF4-FFF2-40B4-BE49-F238E27FC236}">
-                <a16:creationId xmlns:a16="http://schemas.microsoft.com/office/drawing/2014/main" id="{61DB19C8-9A9D-4331-AD36-D3670714451A}"/>
+                <a16:creationId xmlns:a16="http://schemas.microsoft.com/office/drawing/2014/main" id="{8ED85875-0650-4FCB-8EB0-4387A06D0B73}"/>
               </a:ext>
             </a:extLst>
           </p:cNvPr>
@@ -8419,7 +8419,7 @@
           <p:cNvPr id="5" name="">
             <a:extLst xmlns:a="http://schemas.openxmlformats.org/drawingml/2006/main">
               <a:ext uri="{FF2B5EF4-FFF2-40B4-BE49-F238E27FC236}">
-                <a16:creationId xmlns:a16="http://schemas.microsoft.com/office/drawing/2014/main" id="{E7675735-AD5B-4F07-9C35-873FC821C811}"/>
+                <a16:creationId xmlns:a16="http://schemas.microsoft.com/office/drawing/2014/main" id="{DFFB1555-B5C8-4BB1-BE1B-4FEF38616350}"/>
               </a:ext>
             </a:extLst>
           </p:cNvPr>
@@ -8476,7 +8476,7 @@
           <p:cNvPr id="6" name="">
             <a:extLst xmlns:a="http://schemas.openxmlformats.org/drawingml/2006/main">
               <a:ext uri="{FF2B5EF4-FFF2-40B4-BE49-F238E27FC236}">
-                <a16:creationId xmlns:a16="http://schemas.microsoft.com/office/drawing/2014/main" id="{67642F6B-1873-40FB-B934-055DE2A4E13F}"/>
+                <a16:creationId xmlns:a16="http://schemas.microsoft.com/office/drawing/2014/main" id="{39F696ED-CC42-4E0B-BB26-5B97362DF92F}"/>
               </a:ext>
             </a:extLst>
           </p:cNvPr>
@@ -8533,7 +8533,7 @@
           <p:cNvPr id="7" name="">
             <a:extLst xmlns:a="http://schemas.openxmlformats.org/drawingml/2006/main">
               <a:ext uri="{FF2B5EF4-FFF2-40B4-BE49-F238E27FC236}">
-                <a16:creationId xmlns:a16="http://schemas.microsoft.com/office/drawing/2014/main" id="{1946CC20-6AD6-4330-967E-E4340468B94F}"/>
+                <a16:creationId xmlns:a16="http://schemas.microsoft.com/office/drawing/2014/main" id="{39E934ED-BC49-45D0-A501-F338B45BAF5E}"/>
               </a:ext>
             </a:extLst>
           </p:cNvPr>
@@ -8590,7 +8590,7 @@
           <p:cNvPr id="8" name="">
             <a:extLst xmlns:a="http://schemas.openxmlformats.org/drawingml/2006/main">
               <a:ext uri="{FF2B5EF4-FFF2-40B4-BE49-F238E27FC236}">
-                <a16:creationId xmlns:a16="http://schemas.microsoft.com/office/drawing/2014/main" id="{6835F0D9-5D62-4E4E-92E6-EF8173D50669}"/>
+                <a16:creationId xmlns:a16="http://schemas.microsoft.com/office/drawing/2014/main" id="{078BF06B-4C6C-4BFF-8E90-6FE25750D013}"/>
               </a:ext>
             </a:extLst>
           </p:cNvPr>
@@ -8647,7 +8647,7 @@
           <p:cNvPr id="9" name="">
             <a:extLst xmlns:a="http://schemas.openxmlformats.org/drawingml/2006/main">
               <a:ext uri="{FF2B5EF4-FFF2-40B4-BE49-F238E27FC236}">
-                <a16:creationId xmlns:a16="http://schemas.microsoft.com/office/drawing/2014/main" id="{AD0638DD-9127-43AA-8C67-936CEB211EB6}"/>
+                <a16:creationId xmlns:a16="http://schemas.microsoft.com/office/drawing/2014/main" id="{CBE3E4E3-BD65-46BE-8DEB-AB20BAF299D1}"/>
               </a:ext>
             </a:extLst>
           </p:cNvPr>
@@ -8704,7 +8704,7 @@
           <p:cNvPr id="10" name="">
             <a:extLst xmlns:a="http://schemas.openxmlformats.org/drawingml/2006/main">
               <a:ext uri="{FF2B5EF4-FFF2-40B4-BE49-F238E27FC236}">
-                <a16:creationId xmlns:a16="http://schemas.microsoft.com/office/drawing/2014/main" id="{CD6601C6-2D2E-4ACA-B231-85FDDA268917}"/>
+                <a16:creationId xmlns:a16="http://schemas.microsoft.com/office/drawing/2014/main" id="{4C7DE0C0-DA23-4862-A012-A6E1BF278204}"/>
               </a:ext>
             </a:extLst>
           </p:cNvPr>
@@ -8759,7 +8759,7 @@
     </p:spTree>
     <p:extLst>
       <p:ext uri="{BB962C8B-B14F-4D97-AF65-F5344CB8AC3E}">
-        <p14:creationId xmlns:p14="http://schemas.microsoft.com/office/powerpoint/2010/main" val="2073064217"/>
+        <p14:creationId xmlns:p14="http://schemas.microsoft.com/office/powerpoint/2010/main" val="1580988706"/>
       </p:ext>
     </p:extLst>
   </p:cSld>
@@ -8790,7 +8790,7 @@
           <p:cNvPr id="23" name="">
             <a:extLst xmlns:a="http://schemas.openxmlformats.org/drawingml/2006/main">
               <a:ext uri="{FF2B5EF4-FFF2-40B4-BE49-F238E27FC236}">
-                <a16:creationId xmlns:a16="http://schemas.microsoft.com/office/drawing/2014/main" id="{6C02D3CF-1937-43E7-A3D2-6AD2D8D103C6}"/>
+                <a16:creationId xmlns:a16="http://schemas.microsoft.com/office/drawing/2014/main" id="{F35BE9B3-366F-4659-A05C-C12221EC057F}"/>
               </a:ext>
             </a:extLst>
           </p:cNvPr>
@@ -8847,7 +8847,7 @@
           <p:cNvPr id="2" name="">
             <a:extLst xmlns:a="http://schemas.openxmlformats.org/drawingml/2006/main">
               <a:ext uri="{FF2B5EF4-FFF2-40B4-BE49-F238E27FC236}">
-                <a16:creationId xmlns:a16="http://schemas.microsoft.com/office/drawing/2014/main" id="{998916EC-4DF0-4A27-B3D1-9FE8937A774F}"/>
+                <a16:creationId xmlns:a16="http://schemas.microsoft.com/office/drawing/2014/main" id="{49F5C918-57CE-4C3D-AC7F-E482CDF029F2}"/>
               </a:ext>
             </a:extLst>
           </p:cNvPr>
@@ -8904,7 +8904,7 @@
           <p:cNvPr id="3" name="">
             <a:extLst xmlns:a="http://schemas.openxmlformats.org/drawingml/2006/main">
               <a:ext uri="{FF2B5EF4-FFF2-40B4-BE49-F238E27FC236}">
-                <a16:creationId xmlns:a16="http://schemas.microsoft.com/office/drawing/2014/main" id="{FD1C24B5-6673-4007-8DA8-BC17C0935FED}"/>
+                <a16:creationId xmlns:a16="http://schemas.microsoft.com/office/drawing/2014/main" id="{0F024F43-9CB2-43D8-843F-79FF8A097A5A}"/>
               </a:ext>
             </a:extLst>
           </p:cNvPr>
@@ -8936,7 +8936,7 @@
           <p:cNvPr id="4" name="">
             <a:extLst xmlns:a="http://schemas.openxmlformats.org/drawingml/2006/main">
               <a:ext uri="{FF2B5EF4-FFF2-40B4-BE49-F238E27FC236}">
-                <a16:creationId xmlns:a16="http://schemas.microsoft.com/office/drawing/2014/main" id="{5DDE04FB-0EDE-4CF3-9814-8DB467134250}"/>
+                <a16:creationId xmlns:a16="http://schemas.microsoft.com/office/drawing/2014/main" id="{BF00C167-8D2F-4196-9B52-EE1B88372464}"/>
               </a:ext>
             </a:extLst>
           </p:cNvPr>
@@ -8993,7 +8993,7 @@
           <p:cNvPr id="5" name="">
             <a:extLst xmlns:a="http://schemas.openxmlformats.org/drawingml/2006/main">
               <a:ext uri="{FF2B5EF4-FFF2-40B4-BE49-F238E27FC236}">
-                <a16:creationId xmlns:a16="http://schemas.microsoft.com/office/drawing/2014/main" id="{D3536402-BE83-46AC-8DA1-26D9BE7390E6}"/>
+                <a16:creationId xmlns:a16="http://schemas.microsoft.com/office/drawing/2014/main" id="{E820D810-ADD2-463C-9CE7-28F572AAF701}"/>
               </a:ext>
             </a:extLst>
           </p:cNvPr>
@@ -9050,7 +9050,7 @@
           <p:cNvPr id="6" name="">
             <a:extLst xmlns:a="http://schemas.openxmlformats.org/drawingml/2006/main">
               <a:ext uri="{FF2B5EF4-FFF2-40B4-BE49-F238E27FC236}">
-                <a16:creationId xmlns:a16="http://schemas.microsoft.com/office/drawing/2014/main" id="{9FCC1001-DBE0-4FB7-A50E-7ED01DD01465}"/>
+                <a16:creationId xmlns:a16="http://schemas.microsoft.com/office/drawing/2014/main" id="{56E6FD40-8D70-4C56-AAD3-4E8EA84B9CEF}"/>
               </a:ext>
             </a:extLst>
           </p:cNvPr>
@@ -9082,7 +9082,7 @@
           <p:cNvPr id="7" name="">
             <a:extLst xmlns:a="http://schemas.openxmlformats.org/drawingml/2006/main">
               <a:ext uri="{FF2B5EF4-FFF2-40B4-BE49-F238E27FC236}">
-                <a16:creationId xmlns:a16="http://schemas.microsoft.com/office/drawing/2014/main" id="{5F4FF395-FC21-4BFC-B228-AD8E884CEA7F}"/>
+                <a16:creationId xmlns:a16="http://schemas.microsoft.com/office/drawing/2014/main" id="{1CB43707-F665-4E64-8D1A-05FBC6C88ECB}"/>
               </a:ext>
             </a:extLst>
           </p:cNvPr>
@@ -9139,7 +9139,7 @@
           <p:cNvPr id="8" name="">
             <a:extLst xmlns:a="http://schemas.openxmlformats.org/drawingml/2006/main">
               <a:ext uri="{FF2B5EF4-FFF2-40B4-BE49-F238E27FC236}">
-                <a16:creationId xmlns:a16="http://schemas.microsoft.com/office/drawing/2014/main" id="{81D1C802-9AA3-4F18-9EFE-8F20D84C3155}"/>
+                <a16:creationId xmlns:a16="http://schemas.microsoft.com/office/drawing/2014/main" id="{D0A1DE81-D717-49A6-ACE7-79395B3656B6}"/>
               </a:ext>
             </a:extLst>
           </p:cNvPr>
@@ -9196,7 +9196,7 @@
           <p:cNvPr id="9" name="">
             <a:extLst xmlns:a="http://schemas.openxmlformats.org/drawingml/2006/main">
               <a:ext uri="{FF2B5EF4-FFF2-40B4-BE49-F238E27FC236}">
-                <a16:creationId xmlns:a16="http://schemas.microsoft.com/office/drawing/2014/main" id="{07502F96-B4D8-415A-8160-F0C384438EEB}"/>
+                <a16:creationId xmlns:a16="http://schemas.microsoft.com/office/drawing/2014/main" id="{9972EF0F-BE71-47AF-960D-00E608F13D10}"/>
               </a:ext>
             </a:extLst>
           </p:cNvPr>
@@ -9228,7 +9228,7 @@
           <p:cNvPr id="10" name="">
             <a:extLst xmlns:a="http://schemas.openxmlformats.org/drawingml/2006/main">
               <a:ext uri="{FF2B5EF4-FFF2-40B4-BE49-F238E27FC236}">
-                <a16:creationId xmlns:a16="http://schemas.microsoft.com/office/drawing/2014/main" id="{0CB8801B-000C-4F4C-AF37-A19B4C60C430}"/>
+                <a16:creationId xmlns:a16="http://schemas.microsoft.com/office/drawing/2014/main" id="{B7CFE0B3-68CB-419F-9EE8-DFD2FF7CE7BB}"/>
               </a:ext>
             </a:extLst>
           </p:cNvPr>
@@ -9285,7 +9285,7 @@
           <p:cNvPr id="11" name="">
             <a:extLst xmlns:a="http://schemas.openxmlformats.org/drawingml/2006/main">
               <a:ext uri="{FF2B5EF4-FFF2-40B4-BE49-F238E27FC236}">
-                <a16:creationId xmlns:a16="http://schemas.microsoft.com/office/drawing/2014/main" id="{5192CF44-34F8-467F-88DF-9465FAF60FFB}"/>
+                <a16:creationId xmlns:a16="http://schemas.microsoft.com/office/drawing/2014/main" id="{6005E1C7-7908-410C-9BBB-A448D74C0452}"/>
               </a:ext>
             </a:extLst>
           </p:cNvPr>
@@ -9342,7 +9342,7 @@
           <p:cNvPr id="12" name="">
             <a:extLst xmlns:a="http://schemas.openxmlformats.org/drawingml/2006/main">
               <a:ext uri="{FF2B5EF4-FFF2-40B4-BE49-F238E27FC236}">
-                <a16:creationId xmlns:a16="http://schemas.microsoft.com/office/drawing/2014/main" id="{E6B1BDD6-B837-483C-877E-E9F1FC8B5429}"/>
+                <a16:creationId xmlns:a16="http://schemas.microsoft.com/office/drawing/2014/main" id="{FA8CDD98-11FC-4624-8C3B-6A993A788E07}"/>
               </a:ext>
             </a:extLst>
           </p:cNvPr>
@@ -9374,7 +9374,7 @@
           <p:cNvPr id="13" name="">
             <a:extLst xmlns:a="http://schemas.openxmlformats.org/drawingml/2006/main">
               <a:ext uri="{FF2B5EF4-FFF2-40B4-BE49-F238E27FC236}">
-                <a16:creationId xmlns:a16="http://schemas.microsoft.com/office/drawing/2014/main" id="{69A4D9C6-0A8C-40B7-8CCA-7E431CC9FE3A}"/>
+                <a16:creationId xmlns:a16="http://schemas.microsoft.com/office/drawing/2014/main" id="{524FB4F0-E626-4F2C-8D76-C769C1932412}"/>
               </a:ext>
             </a:extLst>
           </p:cNvPr>
@@ -9431,7 +9431,7 @@
           <p:cNvPr id="14" name="">
             <a:extLst xmlns:a="http://schemas.openxmlformats.org/drawingml/2006/main">
               <a:ext uri="{FF2B5EF4-FFF2-40B4-BE49-F238E27FC236}">
-                <a16:creationId xmlns:a16="http://schemas.microsoft.com/office/drawing/2014/main" id="{10A0976B-0D2C-42F4-A02A-2CE3BE6B2384}"/>
+                <a16:creationId xmlns:a16="http://schemas.microsoft.com/office/drawing/2014/main" id="{498CA77E-98B1-4589-8008-7BC07F496B61}"/>
               </a:ext>
             </a:extLst>
           </p:cNvPr>
@@ -9488,7 +9488,7 @@
           <p:cNvPr id="15" name="">
             <a:extLst xmlns:a="http://schemas.openxmlformats.org/drawingml/2006/main">
               <a:ext uri="{FF2B5EF4-FFF2-40B4-BE49-F238E27FC236}">
-                <a16:creationId xmlns:a16="http://schemas.microsoft.com/office/drawing/2014/main" id="{D61FF333-BE24-465C-88E1-E0C1ADAB6707}"/>
+                <a16:creationId xmlns:a16="http://schemas.microsoft.com/office/drawing/2014/main" id="{EACEC1F4-F523-4602-ABB9-A85EBE5014C2}"/>
               </a:ext>
             </a:extLst>
           </p:cNvPr>
@@ -9520,7 +9520,7 @@
           <p:cNvPr id="16" name="">
             <a:extLst xmlns:a="http://schemas.openxmlformats.org/drawingml/2006/main">
               <a:ext uri="{FF2B5EF4-FFF2-40B4-BE49-F238E27FC236}">
-                <a16:creationId xmlns:a16="http://schemas.microsoft.com/office/drawing/2014/main" id="{3C7C94EF-F67B-4D85-976E-C5281CB6E3E4}"/>
+                <a16:creationId xmlns:a16="http://schemas.microsoft.com/office/drawing/2014/main" id="{2D535442-8FA1-4E3F-80A0-1D4D0C2A65FD}"/>
               </a:ext>
             </a:extLst>
           </p:cNvPr>
@@ -9577,7 +9577,7 @@
           <p:cNvPr id="17" name="">
             <a:extLst xmlns:a="http://schemas.openxmlformats.org/drawingml/2006/main">
               <a:ext uri="{FF2B5EF4-FFF2-40B4-BE49-F238E27FC236}">
-                <a16:creationId xmlns:a16="http://schemas.microsoft.com/office/drawing/2014/main" id="{C33315B0-91E4-4DE0-903B-DCDFCCC08F50}"/>
+                <a16:creationId xmlns:a16="http://schemas.microsoft.com/office/drawing/2014/main" id="{036CCE4A-1946-4B96-9F83-5F74D981F769}"/>
               </a:ext>
             </a:extLst>
           </p:cNvPr>
@@ -9742,7 +9742,7 @@
           <p:cNvPr id="22" name="">
             <a:extLst xmlns:a="http://schemas.openxmlformats.org/drawingml/2006/main">
               <a:ext uri="{FF2B5EF4-FFF2-40B4-BE49-F238E27FC236}">
-                <a16:creationId xmlns:a16="http://schemas.microsoft.com/office/drawing/2014/main" id="{F50F2A18-5852-4347-8419-16E0FB923E29}"/>
+                <a16:creationId xmlns:a16="http://schemas.microsoft.com/office/drawing/2014/main" id="{F9AF2016-21DC-43D1-9061-5A6D68068353}"/>
               </a:ext>
             </a:extLst>
           </p:cNvPr>
@@ -9797,7 +9797,7 @@
     </p:spTree>
     <p:extLst>
       <p:ext uri="{BB962C8B-B14F-4D97-AF65-F5344CB8AC3E}">
-        <p14:creationId xmlns:p14="http://schemas.microsoft.com/office/powerpoint/2010/main" val="1589006522"/>
+        <p14:creationId xmlns:p14="http://schemas.microsoft.com/office/powerpoint/2010/main" val="882500254"/>
       </p:ext>
     </p:extLst>
   </p:cSld>
@@ -9828,7 +9828,7 @@
           <p:cNvPr id="13" name="">
             <a:extLst xmlns:a="http://schemas.openxmlformats.org/drawingml/2006/main">
               <a:ext uri="{FF2B5EF4-FFF2-40B4-BE49-F238E27FC236}">
-                <a16:creationId xmlns:a16="http://schemas.microsoft.com/office/drawing/2014/main" id="{D1164D8B-8C50-4EB4-9610-B25D3E0B6F59}"/>
+                <a16:creationId xmlns:a16="http://schemas.microsoft.com/office/drawing/2014/main" id="{5AD71AEA-3665-447D-95BE-A89ABD84D5BC}"/>
               </a:ext>
             </a:extLst>
           </p:cNvPr>
@@ -9885,7 +9885,7 @@
           <p:cNvPr id="2" name="">
             <a:extLst xmlns:a="http://schemas.openxmlformats.org/drawingml/2006/main">
               <a:ext uri="{FF2B5EF4-FFF2-40B4-BE49-F238E27FC236}">
-                <a16:creationId xmlns:a16="http://schemas.microsoft.com/office/drawing/2014/main" id="{BBA3DB97-2B7D-4BDB-9416-94FE744CEDFB}"/>
+                <a16:creationId xmlns:a16="http://schemas.microsoft.com/office/drawing/2014/main" id="{F221A198-584E-41EF-B854-28948EF45FE0}"/>
               </a:ext>
             </a:extLst>
           </p:cNvPr>
@@ -9942,7 +9942,7 @@
           <p:cNvPr id="3" name="">
             <a:extLst xmlns:a="http://schemas.openxmlformats.org/drawingml/2006/main">
               <a:ext uri="{FF2B5EF4-FFF2-40B4-BE49-F238E27FC236}">
-                <a16:creationId xmlns:a16="http://schemas.microsoft.com/office/drawing/2014/main" id="{DCC611BB-9CF0-4115-A35C-36C0F9CAEE6B}"/>
+                <a16:creationId xmlns:a16="http://schemas.microsoft.com/office/drawing/2014/main" id="{9FAA14A5-698F-46C9-9065-6803EC899B54}"/>
               </a:ext>
             </a:extLst>
           </p:cNvPr>
@@ -9999,7 +9999,7 @@
           <p:cNvPr id="4" name="">
             <a:extLst xmlns:a="http://schemas.openxmlformats.org/drawingml/2006/main">
               <a:ext uri="{FF2B5EF4-FFF2-40B4-BE49-F238E27FC236}">
-                <a16:creationId xmlns:a16="http://schemas.microsoft.com/office/drawing/2014/main" id="{B3C76D6C-A518-4029-A796-C7496F313839}"/>
+                <a16:creationId xmlns:a16="http://schemas.microsoft.com/office/drawing/2014/main" id="{3C4310DB-7D7E-40DF-A2FB-F472B261D50A}"/>
               </a:ext>
             </a:extLst>
           </p:cNvPr>
@@ -10056,7 +10056,7 @@
           <p:cNvPr id="5" name="">
             <a:extLst xmlns:a="http://schemas.openxmlformats.org/drawingml/2006/main">
               <a:ext uri="{FF2B5EF4-FFF2-40B4-BE49-F238E27FC236}">
-                <a16:creationId xmlns:a16="http://schemas.microsoft.com/office/drawing/2014/main" id="{5C5D34DE-0682-478E-961E-C97B9A26ABA5}"/>
+                <a16:creationId xmlns:a16="http://schemas.microsoft.com/office/drawing/2014/main" id="{902FFFD5-FBAF-489D-A347-E564B359C0BD}"/>
               </a:ext>
             </a:extLst>
           </p:cNvPr>
@@ -10113,7 +10113,7 @@
           <p:cNvPr id="6" name="">
             <a:extLst xmlns:a="http://schemas.openxmlformats.org/drawingml/2006/main">
               <a:ext uri="{FF2B5EF4-FFF2-40B4-BE49-F238E27FC236}">
-                <a16:creationId xmlns:a16="http://schemas.microsoft.com/office/drawing/2014/main" id="{42A473AB-2600-414F-A089-AE283E2F2A03}"/>
+                <a16:creationId xmlns:a16="http://schemas.microsoft.com/office/drawing/2014/main" id="{36E779B3-C734-4643-BDE5-F455D1FCD8E9}"/>
               </a:ext>
             </a:extLst>
           </p:cNvPr>
@@ -10170,7 +10170,7 @@
           <p:cNvPr id="7" name="">
             <a:extLst xmlns:a="http://schemas.openxmlformats.org/drawingml/2006/main">
               <a:ext uri="{FF2B5EF4-FFF2-40B4-BE49-F238E27FC236}">
-                <a16:creationId xmlns:a16="http://schemas.microsoft.com/office/drawing/2014/main" id="{34BE823C-4B60-4022-9861-8EFE99A24E36}"/>
+                <a16:creationId xmlns:a16="http://schemas.microsoft.com/office/drawing/2014/main" id="{3D846AE5-1366-49EE-8B79-BD70DEA1C5CD}"/>
               </a:ext>
             </a:extLst>
           </p:cNvPr>
@@ -10227,7 +10227,7 @@
           <p:cNvPr id="8" name="">
             <a:extLst xmlns:a="http://schemas.openxmlformats.org/drawingml/2006/main">
               <a:ext uri="{FF2B5EF4-FFF2-40B4-BE49-F238E27FC236}">
-                <a16:creationId xmlns:a16="http://schemas.microsoft.com/office/drawing/2014/main" id="{540B84AB-8239-489E-9BAC-A941579B8A0F}"/>
+                <a16:creationId xmlns:a16="http://schemas.microsoft.com/office/drawing/2014/main" id="{C7D2037F-CFE3-4B71-8FFC-C95962E05DBA}"/>
               </a:ext>
             </a:extLst>
           </p:cNvPr>
@@ -10284,7 +10284,7 @@
           <p:cNvPr id="9" name="">
             <a:extLst xmlns:a="http://schemas.openxmlformats.org/drawingml/2006/main">
               <a:ext uri="{FF2B5EF4-FFF2-40B4-BE49-F238E27FC236}">
-                <a16:creationId xmlns:a16="http://schemas.microsoft.com/office/drawing/2014/main" id="{AF8F09B2-4F50-4C58-93D1-32DC1333F034}"/>
+                <a16:creationId xmlns:a16="http://schemas.microsoft.com/office/drawing/2014/main" id="{3C61AEAC-63B0-4501-AD15-C2767F319AC5}"/>
               </a:ext>
             </a:extLst>
           </p:cNvPr>
@@ -10341,7 +10341,7 @@
           <p:cNvPr id="10" name="">
             <a:extLst xmlns:a="http://schemas.openxmlformats.org/drawingml/2006/main">
               <a:ext uri="{FF2B5EF4-FFF2-40B4-BE49-F238E27FC236}">
-                <a16:creationId xmlns:a16="http://schemas.microsoft.com/office/drawing/2014/main" id="{6E506C88-2337-403A-9DF9-2B0D8CF799F5}"/>
+                <a16:creationId xmlns:a16="http://schemas.microsoft.com/office/drawing/2014/main" id="{73B83EBB-0501-458A-8FD2-4A346F325F27}"/>
               </a:ext>
             </a:extLst>
           </p:cNvPr>
@@ -10398,7 +10398,7 @@
           <p:cNvPr id="11" name="">
             <a:extLst xmlns:a="http://schemas.openxmlformats.org/drawingml/2006/main">
               <a:ext uri="{FF2B5EF4-FFF2-40B4-BE49-F238E27FC236}">
-                <a16:creationId xmlns:a16="http://schemas.microsoft.com/office/drawing/2014/main" id="{4D08E2D5-3784-4C25-A5BB-3E8482B014F0}"/>
+                <a16:creationId xmlns:a16="http://schemas.microsoft.com/office/drawing/2014/main" id="{2F019DA9-3CEF-4A80-A944-ACFEE23B6932}"/>
               </a:ext>
             </a:extLst>
           </p:cNvPr>
@@ -10455,7 +10455,7 @@
           <p:cNvPr id="12" name="">
             <a:extLst xmlns:a="http://schemas.openxmlformats.org/drawingml/2006/main">
               <a:ext uri="{FF2B5EF4-FFF2-40B4-BE49-F238E27FC236}">
-                <a16:creationId xmlns:a16="http://schemas.microsoft.com/office/drawing/2014/main" id="{249959B3-45B5-4CB1-9F1A-52D92E302DE1}"/>
+                <a16:creationId xmlns:a16="http://schemas.microsoft.com/office/drawing/2014/main" id="{73EA334F-C409-4534-B236-DB793127ED68}"/>
               </a:ext>
             </a:extLst>
           </p:cNvPr>
@@ -10510,7 +10510,7 @@
     </p:spTree>
     <p:extLst>
       <p:ext uri="{BB962C8B-B14F-4D97-AF65-F5344CB8AC3E}">
-        <p14:creationId xmlns:p14="http://schemas.microsoft.com/office/powerpoint/2010/main" val="844819502"/>
+        <p14:creationId xmlns:p14="http://schemas.microsoft.com/office/powerpoint/2010/main" val="1559073387"/>
       </p:ext>
     </p:extLst>
   </p:cSld>
@@ -10541,7 +10541,7 @@
           <p:cNvPr id="24" name="">
             <a:extLst xmlns:a="http://schemas.openxmlformats.org/drawingml/2006/main">
               <a:ext uri="{FF2B5EF4-FFF2-40B4-BE49-F238E27FC236}">
-                <a16:creationId xmlns:a16="http://schemas.microsoft.com/office/drawing/2014/main" id="{899FE0B7-3C2A-427C-B5C1-A5D2F2B7B539}"/>
+                <a16:creationId xmlns:a16="http://schemas.microsoft.com/office/drawing/2014/main" id="{0392FD64-08AC-4E8A-89C8-76392EFD91CF}"/>
               </a:ext>
             </a:extLst>
           </p:cNvPr>
@@ -10598,7 +10598,7 @@
           <p:cNvPr id="2" name="">
             <a:extLst xmlns:a="http://schemas.openxmlformats.org/drawingml/2006/main">
               <a:ext uri="{FF2B5EF4-FFF2-40B4-BE49-F238E27FC236}">
-                <a16:creationId xmlns:a16="http://schemas.microsoft.com/office/drawing/2014/main" id="{06921698-1959-480C-893C-7AAE0CD0E092}"/>
+                <a16:creationId xmlns:a16="http://schemas.microsoft.com/office/drawing/2014/main" id="{DF1A4877-7FCE-407E-9AFC-2BB3A60AA149}"/>
               </a:ext>
             </a:extLst>
           </p:cNvPr>
@@ -10655,7 +10655,7 @@
           <p:cNvPr id="3" name="">
             <a:extLst xmlns:a="http://schemas.openxmlformats.org/drawingml/2006/main">
               <a:ext uri="{FF2B5EF4-FFF2-40B4-BE49-F238E27FC236}">
-                <a16:creationId xmlns:a16="http://schemas.microsoft.com/office/drawing/2014/main" id="{691B811B-2462-4431-912E-224B45F50A44}"/>
+                <a16:creationId xmlns:a16="http://schemas.microsoft.com/office/drawing/2014/main" id="{B8C01336-5CC2-44BE-9AD8-B391867F3D06}"/>
               </a:ext>
             </a:extLst>
           </p:cNvPr>
@@ -10687,7 +10687,7 @@
           <p:cNvPr id="4" name="">
             <a:extLst xmlns:a="http://schemas.openxmlformats.org/drawingml/2006/main">
               <a:ext uri="{FF2B5EF4-FFF2-40B4-BE49-F238E27FC236}">
-                <a16:creationId xmlns:a16="http://schemas.microsoft.com/office/drawing/2014/main" id="{5C7D9E2F-D7AC-44D6-843C-AFDE04C2945C}"/>
+                <a16:creationId xmlns:a16="http://schemas.microsoft.com/office/drawing/2014/main" id="{9A4F1358-9CA9-4738-B703-99B466787E52}"/>
               </a:ext>
             </a:extLst>
           </p:cNvPr>
@@ -10744,7 +10744,7 @@
           <p:cNvPr id="5" name="">
             <a:extLst xmlns:a="http://schemas.openxmlformats.org/drawingml/2006/main">
               <a:ext uri="{FF2B5EF4-FFF2-40B4-BE49-F238E27FC236}">
-                <a16:creationId xmlns:a16="http://schemas.microsoft.com/office/drawing/2014/main" id="{2DA5F562-49EC-4A5D-834C-447AE260B111}"/>
+                <a16:creationId xmlns:a16="http://schemas.microsoft.com/office/drawing/2014/main" id="{6A5C5A93-2540-4327-B48A-1161FA88CABB}"/>
               </a:ext>
             </a:extLst>
           </p:cNvPr>
@@ -10801,7 +10801,7 @@
           <p:cNvPr id="6" name="">
             <a:extLst xmlns:a="http://schemas.openxmlformats.org/drawingml/2006/main">
               <a:ext uri="{FF2B5EF4-FFF2-40B4-BE49-F238E27FC236}">
-                <a16:creationId xmlns:a16="http://schemas.microsoft.com/office/drawing/2014/main" id="{A731F405-5BB5-4E4C-A5AE-CB465505E9BE}"/>
+                <a16:creationId xmlns:a16="http://schemas.microsoft.com/office/drawing/2014/main" id="{ECB42E22-2F64-44C9-83AE-3E93F4540F66}"/>
               </a:ext>
             </a:extLst>
           </p:cNvPr>
@@ -10833,7 +10833,7 @@
           <p:cNvPr id="7" name="">
             <a:extLst xmlns:a="http://schemas.openxmlformats.org/drawingml/2006/main">
               <a:ext uri="{FF2B5EF4-FFF2-40B4-BE49-F238E27FC236}">
-                <a16:creationId xmlns:a16="http://schemas.microsoft.com/office/drawing/2014/main" id="{19C1D7DF-94A4-4434-95D0-92E855AD478A}"/>
+                <a16:creationId xmlns:a16="http://schemas.microsoft.com/office/drawing/2014/main" id="{5FBC2E9A-572A-461F-9789-18AC6A4D67C7}"/>
               </a:ext>
             </a:extLst>
           </p:cNvPr>
@@ -10890,7 +10890,7 @@
           <p:cNvPr id="8" name="">
             <a:extLst xmlns:a="http://schemas.openxmlformats.org/drawingml/2006/main">
               <a:ext uri="{FF2B5EF4-FFF2-40B4-BE49-F238E27FC236}">
-                <a16:creationId xmlns:a16="http://schemas.microsoft.com/office/drawing/2014/main" id="{C17573E5-5910-40AA-8FB0-2AB5F1E915B1}"/>
+                <a16:creationId xmlns:a16="http://schemas.microsoft.com/office/drawing/2014/main" id="{9C0AF9B8-A6A8-4AE4-B315-F0EE4BADDBFB}"/>
               </a:ext>
             </a:extLst>
           </p:cNvPr>
@@ -10972,7 +10972,7 @@
           <p:cNvPr id="10" name="">
             <a:extLst xmlns:a="http://schemas.openxmlformats.org/drawingml/2006/main">
               <a:ext uri="{FF2B5EF4-FFF2-40B4-BE49-F238E27FC236}">
-                <a16:creationId xmlns:a16="http://schemas.microsoft.com/office/drawing/2014/main" id="{30C1307C-AFEC-425A-AAE0-917B4FC118C2}"/>
+                <a16:creationId xmlns:a16="http://schemas.microsoft.com/office/drawing/2014/main" id="{B47C2BEE-25AB-4964-B9E5-CAC5759F8500}"/>
               </a:ext>
             </a:extLst>
           </p:cNvPr>
@@ -11004,7 +11004,7 @@
           <p:cNvPr id="11" name="">
             <a:extLst xmlns:a="http://schemas.openxmlformats.org/drawingml/2006/main">
               <a:ext uri="{FF2B5EF4-FFF2-40B4-BE49-F238E27FC236}">
-                <a16:creationId xmlns:a16="http://schemas.microsoft.com/office/drawing/2014/main" id="{055A3FB3-F29B-45A2-B68E-B213FABFF0F4}"/>
+                <a16:creationId xmlns:a16="http://schemas.microsoft.com/office/drawing/2014/main" id="{411A3175-04E1-4170-8ADF-B8F4E1A61AD2}"/>
               </a:ext>
             </a:extLst>
           </p:cNvPr>
@@ -11061,7 +11061,7 @@
           <p:cNvPr id="12" name="">
             <a:extLst xmlns:a="http://schemas.openxmlformats.org/drawingml/2006/main">
               <a:ext uri="{FF2B5EF4-FFF2-40B4-BE49-F238E27FC236}">
-                <a16:creationId xmlns:a16="http://schemas.microsoft.com/office/drawing/2014/main" id="{E29958C1-5150-41E4-8B0C-146F8F2178CC}"/>
+                <a16:creationId xmlns:a16="http://schemas.microsoft.com/office/drawing/2014/main" id="{95AE76F9-FC23-4E60-A387-2D1CCFA1CB7B}"/>
               </a:ext>
             </a:extLst>
           </p:cNvPr>
@@ -11143,7 +11143,7 @@
           <p:cNvPr id="14" name="">
             <a:extLst xmlns:a="http://schemas.openxmlformats.org/drawingml/2006/main">
               <a:ext uri="{FF2B5EF4-FFF2-40B4-BE49-F238E27FC236}">
-                <a16:creationId xmlns:a16="http://schemas.microsoft.com/office/drawing/2014/main" id="{D818B217-BF60-4D36-91C7-FCFA6B346680}"/>
+                <a16:creationId xmlns:a16="http://schemas.microsoft.com/office/drawing/2014/main" id="{7151DC95-1F8B-40D6-9583-C322E4AF7FC8}"/>
               </a:ext>
             </a:extLst>
           </p:cNvPr>
@@ -11175,7 +11175,7 @@
           <p:cNvPr id="15" name="">
             <a:extLst xmlns:a="http://schemas.openxmlformats.org/drawingml/2006/main">
               <a:ext uri="{FF2B5EF4-FFF2-40B4-BE49-F238E27FC236}">
-                <a16:creationId xmlns:a16="http://schemas.microsoft.com/office/drawing/2014/main" id="{9DFF62E2-FDDE-4C97-9D7A-9A7213047CCB}"/>
+                <a16:creationId xmlns:a16="http://schemas.microsoft.com/office/drawing/2014/main" id="{F03C31F5-B81D-4A4B-9C23-F927496ECB2C}"/>
               </a:ext>
             </a:extLst>
           </p:cNvPr>
@@ -11232,7 +11232,7 @@
           <p:cNvPr id="16" name="">
             <a:extLst xmlns:a="http://schemas.openxmlformats.org/drawingml/2006/main">
               <a:ext uri="{FF2B5EF4-FFF2-40B4-BE49-F238E27FC236}">
-                <a16:creationId xmlns:a16="http://schemas.microsoft.com/office/drawing/2014/main" id="{F90B5D71-E787-458D-9840-46AF57E06B4A}"/>
+                <a16:creationId xmlns:a16="http://schemas.microsoft.com/office/drawing/2014/main" id="{87D4566A-ADA6-4687-817C-44F00D0D8B6B}"/>
               </a:ext>
             </a:extLst>
           </p:cNvPr>
@@ -11314,7 +11314,7 @@
           <p:cNvPr id="18" name="">
             <a:extLst xmlns:a="http://schemas.openxmlformats.org/drawingml/2006/main">
               <a:ext uri="{FF2B5EF4-FFF2-40B4-BE49-F238E27FC236}">
-                <a16:creationId xmlns:a16="http://schemas.microsoft.com/office/drawing/2014/main" id="{7688DA8F-F6BB-4E15-B6D9-F092609E0135}"/>
+                <a16:creationId xmlns:a16="http://schemas.microsoft.com/office/drawing/2014/main" id="{9D231E80-AED1-4AFC-8F99-F41642113890}"/>
               </a:ext>
             </a:extLst>
           </p:cNvPr>
@@ -11346,7 +11346,7 @@
           <p:cNvPr id="19" name="">
             <a:extLst xmlns:a="http://schemas.openxmlformats.org/drawingml/2006/main">
               <a:ext uri="{FF2B5EF4-FFF2-40B4-BE49-F238E27FC236}">
-                <a16:creationId xmlns:a16="http://schemas.microsoft.com/office/drawing/2014/main" id="{46E3B714-DFAC-4E22-B5DB-6210B19063AC}"/>
+                <a16:creationId xmlns:a16="http://schemas.microsoft.com/office/drawing/2014/main" id="{C90DC807-27DA-4DFC-B49C-5469388F4B7D}"/>
               </a:ext>
             </a:extLst>
           </p:cNvPr>
@@ -11403,7 +11403,7 @@
           <p:cNvPr id="20" name="">
             <a:extLst xmlns:a="http://schemas.openxmlformats.org/drawingml/2006/main">
               <a:ext uri="{FF2B5EF4-FFF2-40B4-BE49-F238E27FC236}">
-                <a16:creationId xmlns:a16="http://schemas.microsoft.com/office/drawing/2014/main" id="{923762D6-C4F5-4B67-A8FB-F042294C1A32}"/>
+                <a16:creationId xmlns:a16="http://schemas.microsoft.com/office/drawing/2014/main" id="{73769800-3695-4DFE-ADA6-112955579977}"/>
               </a:ext>
             </a:extLst>
           </p:cNvPr>
@@ -11485,7 +11485,7 @@
           <p:cNvPr id="22" name="">
             <a:extLst xmlns:a="http://schemas.openxmlformats.org/drawingml/2006/main">
               <a:ext uri="{FF2B5EF4-FFF2-40B4-BE49-F238E27FC236}">
-                <a16:creationId xmlns:a16="http://schemas.microsoft.com/office/drawing/2014/main" id="{EBFBA63D-FE70-43AE-B94D-AF491CE307C3}"/>
+                <a16:creationId xmlns:a16="http://schemas.microsoft.com/office/drawing/2014/main" id="{BD43E99C-58A2-4A77-B42E-CA0380E2D696}"/>
               </a:ext>
             </a:extLst>
           </p:cNvPr>
@@ -11542,7 +11542,7 @@
           <p:cNvPr id="23" name="">
             <a:extLst xmlns:a="http://schemas.openxmlformats.org/drawingml/2006/main">
               <a:ext uri="{FF2B5EF4-FFF2-40B4-BE49-F238E27FC236}">
-                <a16:creationId xmlns:a16="http://schemas.microsoft.com/office/drawing/2014/main" id="{110A1C54-BBAD-48CC-8938-00E1C847A887}"/>
+                <a16:creationId xmlns:a16="http://schemas.microsoft.com/office/drawing/2014/main" id="{C849EEFA-38E4-4080-BDEA-0F80E103F569}"/>
               </a:ext>
             </a:extLst>
           </p:cNvPr>
@@ -11597,7 +11597,7 @@
     </p:spTree>
     <p:extLst>
       <p:ext uri="{BB962C8B-B14F-4D97-AF65-F5344CB8AC3E}">
-        <p14:creationId xmlns:p14="http://schemas.microsoft.com/office/powerpoint/2010/main" val="673589129"/>
+        <p14:creationId xmlns:p14="http://schemas.microsoft.com/office/powerpoint/2010/main" val="311106037"/>
       </p:ext>
     </p:extLst>
   </p:cSld>
@@ -11628,7 +11628,7 @@
           <p:cNvPr id="6" name="">
             <a:extLst xmlns:a="http://schemas.openxmlformats.org/drawingml/2006/main">
               <a:ext uri="{FF2B5EF4-FFF2-40B4-BE49-F238E27FC236}">
-                <a16:creationId xmlns:a16="http://schemas.microsoft.com/office/drawing/2014/main" id="{CA0D8164-93C6-4CEF-ABB2-E3526564FAE2}"/>
+                <a16:creationId xmlns:a16="http://schemas.microsoft.com/office/drawing/2014/main" id="{EF5E3064-A35F-40A3-961E-62E95A92C05E}"/>
               </a:ext>
             </a:extLst>
           </p:cNvPr>
@@ -11685,7 +11685,7 @@
           <p:cNvPr id="2" name="">
             <a:extLst xmlns:a="http://schemas.openxmlformats.org/drawingml/2006/main">
               <a:ext uri="{FF2B5EF4-FFF2-40B4-BE49-F238E27FC236}">
-                <a16:creationId xmlns:a16="http://schemas.microsoft.com/office/drawing/2014/main" id="{414A37F6-F365-4869-9CE6-45F5B6D11805}"/>
+                <a16:creationId xmlns:a16="http://schemas.microsoft.com/office/drawing/2014/main" id="{5CF287EC-0B8B-4A1B-86E7-349087ED593C}"/>
               </a:ext>
             </a:extLst>
           </p:cNvPr>
@@ -11742,7 +11742,7 @@
           <p:cNvPr id="3" name="">
             <a:extLst xmlns:a="http://schemas.openxmlformats.org/drawingml/2006/main">
               <a:ext uri="{FF2B5EF4-FFF2-40B4-BE49-F238E27FC236}">
-                <a16:creationId xmlns:a16="http://schemas.microsoft.com/office/drawing/2014/main" id="{833D9D01-CC0A-4BBD-9B14-94F4A85D4DE2}"/>
+                <a16:creationId xmlns:a16="http://schemas.microsoft.com/office/drawing/2014/main" id="{AD3422D6-0386-4498-8F63-1ACAF012186D}"/>
               </a:ext>
             </a:extLst>
           </p:cNvPr>
@@ -11803,7 +11803,7 @@
           <p:nvPr/>
         </p:nvPicPr>
         <p:blipFill>
-          <a:blip xmlns:r="http://schemas.openxmlformats.org/officeDocument/2006/relationships" xmlns:a="http://schemas.openxmlformats.org/drawingml/2006/main" r:embed="R60c6d444d1b046de"/>
+          <a:blip xmlns:r="http://schemas.openxmlformats.org/officeDocument/2006/relationships" xmlns:a="http://schemas.openxmlformats.org/drawingml/2006/main" r:embed="R4dd9d680c4ba4e86"/>
           <a:stretch xmlns:a="http://schemas.openxmlformats.org/drawingml/2006/main"/>
         </p:blipFill>
         <p:spPr>
@@ -11821,7 +11821,7 @@
           <p:cNvPr id="5" name="">
             <a:extLst xmlns:a="http://schemas.openxmlformats.org/drawingml/2006/main">
               <a:ext uri="{FF2B5EF4-FFF2-40B4-BE49-F238E27FC236}">
-                <a16:creationId xmlns:a16="http://schemas.microsoft.com/office/drawing/2014/main" id="{76264972-B894-4824-A736-A54D64BB09DB}"/>
+                <a16:creationId xmlns:a16="http://schemas.microsoft.com/office/drawing/2014/main" id="{0FEE72E9-7241-4CE6-9C21-60498D315B64}"/>
               </a:ext>
             </a:extLst>
           </p:cNvPr>
@@ -11932,7 +11932,7 @@
     </p:spTree>
     <p:extLst>
       <p:ext uri="{BB962C8B-B14F-4D97-AF65-F5344CB8AC3E}">
-        <p14:creationId xmlns:p14="http://schemas.microsoft.com/office/powerpoint/2010/main" val="2105259725"/>
+        <p14:creationId xmlns:p14="http://schemas.microsoft.com/office/powerpoint/2010/main" val="118883730"/>
       </p:ext>
     </p:extLst>
   </p:cSld>
@@ -11963,7 +11963,7 @@
           <p:cNvPr id="5" name="">
             <a:extLst xmlns:a="http://schemas.openxmlformats.org/drawingml/2006/main">
               <a:ext uri="{FF2B5EF4-FFF2-40B4-BE49-F238E27FC236}">
-                <a16:creationId xmlns:a16="http://schemas.microsoft.com/office/drawing/2014/main" id="{51630E19-F68C-403A-867B-CE7A44BCF740}"/>
+                <a16:creationId xmlns:a16="http://schemas.microsoft.com/office/drawing/2014/main" id="{1408A74C-66A7-455F-AB48-BABDAF9977EB}"/>
               </a:ext>
             </a:extLst>
           </p:cNvPr>
@@ -12020,7 +12020,7 @@
           <p:cNvPr id="2" name="">
             <a:extLst xmlns:a="http://schemas.openxmlformats.org/drawingml/2006/main">
               <a:ext uri="{FF2B5EF4-FFF2-40B4-BE49-F238E27FC236}">
-                <a16:creationId xmlns:a16="http://schemas.microsoft.com/office/drawing/2014/main" id="{B2262BCE-1C88-47B5-81EC-93A25157D407}"/>
+                <a16:creationId xmlns:a16="http://schemas.microsoft.com/office/drawing/2014/main" id="{86DCD973-237C-4F84-B8F7-1589C51731E6}"/>
               </a:ext>
             </a:extLst>
           </p:cNvPr>
@@ -12081,7 +12081,7 @@
           <p:nvPr/>
         </p:nvPicPr>
         <p:blipFill>
-          <a:blip xmlns:r="http://schemas.openxmlformats.org/officeDocument/2006/relationships" xmlns:a="http://schemas.openxmlformats.org/drawingml/2006/main" r:embed="R7a61cb6a11a34d50"/>
+          <a:blip xmlns:r="http://schemas.openxmlformats.org/officeDocument/2006/relationships" xmlns:a="http://schemas.openxmlformats.org/drawingml/2006/main" r:embed="Rd324246e601e47a9"/>
           <a:stretch xmlns:a="http://schemas.openxmlformats.org/drawingml/2006/main"/>
         </p:blipFill>
         <p:spPr>
@@ -12099,7 +12099,7 @@
           <p:cNvPr id="4" name="">
             <a:extLst xmlns:a="http://schemas.openxmlformats.org/drawingml/2006/main">
               <a:ext uri="{FF2B5EF4-FFF2-40B4-BE49-F238E27FC236}">
-                <a16:creationId xmlns:a16="http://schemas.microsoft.com/office/drawing/2014/main" id="{A1A28CF9-532B-4942-9DC8-22A323632492}"/>
+                <a16:creationId xmlns:a16="http://schemas.microsoft.com/office/drawing/2014/main" id="{99A52D50-08D1-4F82-AD14-A31E4F537BBA}"/>
               </a:ext>
             </a:extLst>
           </p:cNvPr>
@@ -12266,7 +12266,7 @@
     </p:spTree>
     <p:extLst>
       <p:ext uri="{BB962C8B-B14F-4D97-AF65-F5344CB8AC3E}">
-        <p14:creationId xmlns:p14="http://schemas.microsoft.com/office/powerpoint/2010/main" val="478301587"/>
+        <p14:creationId xmlns:p14="http://schemas.microsoft.com/office/powerpoint/2010/main" val="433072152"/>
       </p:ext>
     </p:extLst>
   </p:cSld>
@@ -12297,7 +12297,7 @@
           <p:cNvPr id="5" name="">
             <a:extLst xmlns:a="http://schemas.openxmlformats.org/drawingml/2006/main">
               <a:ext uri="{FF2B5EF4-FFF2-40B4-BE49-F238E27FC236}">
-                <a16:creationId xmlns:a16="http://schemas.microsoft.com/office/drawing/2014/main" id="{C3D390D2-0F86-4E46-8151-D1F779F2331B}"/>
+                <a16:creationId xmlns:a16="http://schemas.microsoft.com/office/drawing/2014/main" id="{2C43E933-2BAD-4623-AC1B-FDF43FD7DE3F}"/>
               </a:ext>
             </a:extLst>
           </p:cNvPr>
@@ -12354,7 +12354,7 @@
           <p:cNvPr id="2" name="">
             <a:extLst xmlns:a="http://schemas.openxmlformats.org/drawingml/2006/main">
               <a:ext uri="{FF2B5EF4-FFF2-40B4-BE49-F238E27FC236}">
-                <a16:creationId xmlns:a16="http://schemas.microsoft.com/office/drawing/2014/main" id="{8A01F3B9-AF7C-48C1-8AAA-2C9E74FA7625}"/>
+                <a16:creationId xmlns:a16="http://schemas.microsoft.com/office/drawing/2014/main" id="{2BC4CB98-6490-4D6B-BFE4-4B3F98CF552F}"/>
               </a:ext>
             </a:extLst>
           </p:cNvPr>
@@ -12415,7 +12415,7 @@
           <p:nvPr/>
         </p:nvPicPr>
         <p:blipFill>
-          <a:blip xmlns:r="http://schemas.openxmlformats.org/officeDocument/2006/relationships" xmlns:a="http://schemas.openxmlformats.org/drawingml/2006/main" r:embed="R1bd979fc099b4b99"/>
+          <a:blip xmlns:r="http://schemas.openxmlformats.org/officeDocument/2006/relationships" xmlns:a="http://schemas.openxmlformats.org/drawingml/2006/main" r:embed="Rce31ef25137046cf"/>
           <a:stretch xmlns:a="http://schemas.openxmlformats.org/drawingml/2006/main"/>
         </p:blipFill>
         <p:spPr>
@@ -12433,7 +12433,7 @@
           <p:cNvPr id="4" name="">
             <a:extLst xmlns:a="http://schemas.openxmlformats.org/drawingml/2006/main">
               <a:ext uri="{FF2B5EF4-FFF2-40B4-BE49-F238E27FC236}">
-                <a16:creationId xmlns:a16="http://schemas.microsoft.com/office/drawing/2014/main" id="{C36C677D-31BB-410C-BF15-52196FED4611}"/>
+                <a16:creationId xmlns:a16="http://schemas.microsoft.com/office/drawing/2014/main" id="{EC5C8F29-93F3-4E62-9334-5E7517826A4D}"/>
               </a:ext>
             </a:extLst>
           </p:cNvPr>
@@ -12600,7 +12600,7 @@
     </p:spTree>
     <p:extLst>
       <p:ext uri="{BB962C8B-B14F-4D97-AF65-F5344CB8AC3E}">
-        <p14:creationId xmlns:p14="http://schemas.microsoft.com/office/powerpoint/2010/main" val="958811569"/>
+        <p14:creationId xmlns:p14="http://schemas.microsoft.com/office/powerpoint/2010/main" val="1297435558"/>
       </p:ext>
     </p:extLst>
   </p:cSld>
@@ -12631,7 +12631,7 @@
           <p:cNvPr id="5" name="">
             <a:extLst xmlns:a="http://schemas.openxmlformats.org/drawingml/2006/main">
               <a:ext uri="{FF2B5EF4-FFF2-40B4-BE49-F238E27FC236}">
-                <a16:creationId xmlns:a16="http://schemas.microsoft.com/office/drawing/2014/main" id="{E8788DA7-B52F-43A2-BF71-ADA54D537899}"/>
+                <a16:creationId xmlns:a16="http://schemas.microsoft.com/office/drawing/2014/main" id="{D39121F3-6C78-424F-B328-0CC4B88AA034}"/>
               </a:ext>
             </a:extLst>
           </p:cNvPr>
@@ -12688,7 +12688,7 @@
           <p:cNvPr id="2" name="">
             <a:extLst xmlns:a="http://schemas.openxmlformats.org/drawingml/2006/main">
               <a:ext uri="{FF2B5EF4-FFF2-40B4-BE49-F238E27FC236}">
-                <a16:creationId xmlns:a16="http://schemas.microsoft.com/office/drawing/2014/main" id="{76351B08-4FD9-45D9-9014-314CB9781173}"/>
+                <a16:creationId xmlns:a16="http://schemas.microsoft.com/office/drawing/2014/main" id="{2D9645A6-5D29-41AB-8ADE-5A5FF95B39AF}"/>
               </a:ext>
             </a:extLst>
           </p:cNvPr>
@@ -12749,7 +12749,7 @@
           <p:nvPr/>
         </p:nvPicPr>
         <p:blipFill>
-          <a:blip xmlns:r="http://schemas.openxmlformats.org/officeDocument/2006/relationships" xmlns:a="http://schemas.openxmlformats.org/drawingml/2006/main" r:embed="R1d56af631d4c472a"/>
+          <a:blip xmlns:r="http://schemas.openxmlformats.org/officeDocument/2006/relationships" xmlns:a="http://schemas.openxmlformats.org/drawingml/2006/main" r:embed="Rc02854231ccb4f67"/>
           <a:stretch xmlns:a="http://schemas.openxmlformats.org/drawingml/2006/main"/>
         </p:blipFill>
         <p:spPr>
@@ -12767,7 +12767,7 @@
           <p:cNvPr id="4" name="">
             <a:extLst xmlns:a="http://schemas.openxmlformats.org/drawingml/2006/main">
               <a:ext uri="{FF2B5EF4-FFF2-40B4-BE49-F238E27FC236}">
-                <a16:creationId xmlns:a16="http://schemas.microsoft.com/office/drawing/2014/main" id="{AFF3F814-9B84-446D-ADFA-44D3A010932E}"/>
+                <a16:creationId xmlns:a16="http://schemas.microsoft.com/office/drawing/2014/main" id="{7C4F66B6-7EDA-48A0-89A7-5A5759122615}"/>
               </a:ext>
             </a:extLst>
           </p:cNvPr>
@@ -12934,7 +12934,7 @@
     </p:spTree>
     <p:extLst>
       <p:ext uri="{BB962C8B-B14F-4D97-AF65-F5344CB8AC3E}">
-        <p14:creationId xmlns:p14="http://schemas.microsoft.com/office/powerpoint/2010/main" val="1890088105"/>
+        <p14:creationId xmlns:p14="http://schemas.microsoft.com/office/powerpoint/2010/main" val="738790640"/>
       </p:ext>
     </p:extLst>
   </p:cSld>

</xml_diff>